<commit_message>
Render basic PPTX text boxes
</commit_message>
<xml_diff>
--- a/tests/Lokad.OoxPdf.Tests/Cases/pptx-blank.pptx
+++ b/tests/Lokad.OoxPdf.Tests/Cases/pptx-blank.pptx
@@ -129,7 +129,7 @@
           <p:cNvPr id="2" name="Title 1">
             <a:extLst>
               <a:ext uri="{FF2B5EF4-FFF2-40B4-BE49-F238E27FC236}">
-                <a16:creationId xmlns:a16="http://schemas.microsoft.com/office/drawing/2014/main" id="{74F2C3E5-89FF-BCC8-982E-4694755EAE1E}"/>
+                <a16:creationId xmlns:a16="http://schemas.microsoft.com/office/drawing/2014/main" id="{94CD72B9-FF87-ACA7-B12B-134C268890D3}"/>
               </a:ext>
             </a:extLst>
           </p:cNvPr>
@@ -166,7 +166,7 @@
           <p:cNvPr id="3" name="Subtitle 2">
             <a:extLst>
               <a:ext uri="{FF2B5EF4-FFF2-40B4-BE49-F238E27FC236}">
-                <a16:creationId xmlns:a16="http://schemas.microsoft.com/office/drawing/2014/main" id="{969DFFB8-B052-4750-F040-E51EF02A44BF}"/>
+                <a16:creationId xmlns:a16="http://schemas.microsoft.com/office/drawing/2014/main" id="{F253B2CF-A452-0A98-0F9C-CC3EBE15BF06}"/>
               </a:ext>
             </a:extLst>
           </p:cNvPr>
@@ -236,7 +236,7 @@
           <p:cNvPr id="4" name="Date Placeholder 3">
             <a:extLst>
               <a:ext uri="{FF2B5EF4-FFF2-40B4-BE49-F238E27FC236}">
-                <a16:creationId xmlns:a16="http://schemas.microsoft.com/office/drawing/2014/main" id="{FD678FDE-7C50-0A66-1A41-77020D4BFC8E}"/>
+                <a16:creationId xmlns:a16="http://schemas.microsoft.com/office/drawing/2014/main" id="{BFD59B7F-CC80-D389-B8EF-0097B6FE365F}"/>
               </a:ext>
             </a:extLst>
           </p:cNvPr>
@@ -252,7 +252,7 @@
           <a:bodyPr/>
           <a:lstStyle/>
           <a:p>
-            <a:fld id="{E73F329E-F2C3-4FC1-87DF-80EBA0D93720}" type="datetimeFigureOut">
+            <a:fld id="{FD3911C1-3A98-4A4A-AB0A-8F4CBA820BBB}" type="datetimeFigureOut">
               <a:rPr lang="en-US" smtClean="0"/>
               <a:t>5/14/2026</a:t>
             </a:fld>
@@ -265,7 +265,7 @@
           <p:cNvPr id="5" name="Footer Placeholder 4">
             <a:extLst>
               <a:ext uri="{FF2B5EF4-FFF2-40B4-BE49-F238E27FC236}">
-                <a16:creationId xmlns:a16="http://schemas.microsoft.com/office/drawing/2014/main" id="{05298E97-8668-4577-2681-A4FB3D6DCF51}"/>
+                <a16:creationId xmlns:a16="http://schemas.microsoft.com/office/drawing/2014/main" id="{684E87BB-BC04-4B62-E177-16DE3E47D34C}"/>
               </a:ext>
             </a:extLst>
           </p:cNvPr>
@@ -290,7 +290,7 @@
           <p:cNvPr id="6" name="Slide Number Placeholder 5">
             <a:extLst>
               <a:ext uri="{FF2B5EF4-FFF2-40B4-BE49-F238E27FC236}">
-                <a16:creationId xmlns:a16="http://schemas.microsoft.com/office/drawing/2014/main" id="{5C4F449C-FD57-1A1C-66C4-6D3838F7D814}"/>
+                <a16:creationId xmlns:a16="http://schemas.microsoft.com/office/drawing/2014/main" id="{A7A4EC9C-321D-1E5A-4B07-E6FEF4571BEC}"/>
               </a:ext>
             </a:extLst>
           </p:cNvPr>
@@ -306,7 +306,7 @@
           <a:bodyPr/>
           <a:lstStyle/>
           <a:p>
-            <a:fld id="{2A94C4E9-1398-414E-8DBD-9BE78B34AE56}" type="slidenum">
+            <a:fld id="{2A514CDA-1E74-420B-BC3B-A7D966BDE689}" type="slidenum">
               <a:rPr lang="en-US" smtClean="0"/>
               <a:t>‹#›</a:t>
             </a:fld>
@@ -317,7 +317,7 @@
     </p:spTree>
     <p:extLst>
       <p:ext uri="{BB962C8B-B14F-4D97-AF65-F5344CB8AC3E}">
-        <p14:creationId xmlns:p14="http://schemas.microsoft.com/office/powerpoint/2010/main" val="482878507"/>
+        <p14:creationId xmlns:p14="http://schemas.microsoft.com/office/powerpoint/2010/main" val="340045867"/>
       </p:ext>
     </p:extLst>
   </p:cSld>
@@ -349,7 +349,7 @@
           <p:cNvPr id="2" name="Title 1">
             <a:extLst>
               <a:ext uri="{FF2B5EF4-FFF2-40B4-BE49-F238E27FC236}">
-                <a16:creationId xmlns:a16="http://schemas.microsoft.com/office/drawing/2014/main" id="{3964FAF3-B54D-8B58-1EA6-C3F9C06AB830}"/>
+                <a16:creationId xmlns:a16="http://schemas.microsoft.com/office/drawing/2014/main" id="{75657439-1DD1-31D9-E6C8-06D3293C99CB}"/>
               </a:ext>
             </a:extLst>
           </p:cNvPr>
@@ -377,7 +377,7 @@
           <p:cNvPr id="3" name="Vertical Text Placeholder 2">
             <a:extLst>
               <a:ext uri="{FF2B5EF4-FFF2-40B4-BE49-F238E27FC236}">
-                <a16:creationId xmlns:a16="http://schemas.microsoft.com/office/drawing/2014/main" id="{E5DFBBAF-BD6B-F259-36A1-E3114215609D}"/>
+                <a16:creationId xmlns:a16="http://schemas.microsoft.com/office/drawing/2014/main" id="{AB7A188A-9B1D-9826-9BA5-748DEF7DAF9B}"/>
               </a:ext>
             </a:extLst>
           </p:cNvPr>
@@ -434,7 +434,7 @@
           <p:cNvPr id="4" name="Date Placeholder 3">
             <a:extLst>
               <a:ext uri="{FF2B5EF4-FFF2-40B4-BE49-F238E27FC236}">
-                <a16:creationId xmlns:a16="http://schemas.microsoft.com/office/drawing/2014/main" id="{0162C8F5-1D16-793D-CBE9-2AAF9B7093BC}"/>
+                <a16:creationId xmlns:a16="http://schemas.microsoft.com/office/drawing/2014/main" id="{3541695A-F3B9-4952-C817-1D2A7D6B23B7}"/>
               </a:ext>
             </a:extLst>
           </p:cNvPr>
@@ -450,7 +450,7 @@
           <a:bodyPr/>
           <a:lstStyle/>
           <a:p>
-            <a:fld id="{E73F329E-F2C3-4FC1-87DF-80EBA0D93720}" type="datetimeFigureOut">
+            <a:fld id="{FD3911C1-3A98-4A4A-AB0A-8F4CBA820BBB}" type="datetimeFigureOut">
               <a:rPr lang="en-US" smtClean="0"/>
               <a:t>5/14/2026</a:t>
             </a:fld>
@@ -463,7 +463,7 @@
           <p:cNvPr id="5" name="Footer Placeholder 4">
             <a:extLst>
               <a:ext uri="{FF2B5EF4-FFF2-40B4-BE49-F238E27FC236}">
-                <a16:creationId xmlns:a16="http://schemas.microsoft.com/office/drawing/2014/main" id="{91D6418F-E203-A75C-0179-8904735ABA8F}"/>
+                <a16:creationId xmlns:a16="http://schemas.microsoft.com/office/drawing/2014/main" id="{63A88DBC-AAC8-ED1E-9FBA-E3254189ED61}"/>
               </a:ext>
             </a:extLst>
           </p:cNvPr>
@@ -488,7 +488,7 @@
           <p:cNvPr id="6" name="Slide Number Placeholder 5">
             <a:extLst>
               <a:ext uri="{FF2B5EF4-FFF2-40B4-BE49-F238E27FC236}">
-                <a16:creationId xmlns:a16="http://schemas.microsoft.com/office/drawing/2014/main" id="{78696CD5-945F-E492-9E86-0F06B55A00A6}"/>
+                <a16:creationId xmlns:a16="http://schemas.microsoft.com/office/drawing/2014/main" id="{EAA0ABBD-A5EC-295C-0411-CBD6B61FD46E}"/>
               </a:ext>
             </a:extLst>
           </p:cNvPr>
@@ -504,7 +504,7 @@
           <a:bodyPr/>
           <a:lstStyle/>
           <a:p>
-            <a:fld id="{2A94C4E9-1398-414E-8DBD-9BE78B34AE56}" type="slidenum">
+            <a:fld id="{2A514CDA-1E74-420B-BC3B-A7D966BDE689}" type="slidenum">
               <a:rPr lang="en-US" smtClean="0"/>
               <a:t>‹#›</a:t>
             </a:fld>
@@ -515,7 +515,7 @@
     </p:spTree>
     <p:extLst>
       <p:ext uri="{BB962C8B-B14F-4D97-AF65-F5344CB8AC3E}">
-        <p14:creationId xmlns:p14="http://schemas.microsoft.com/office/powerpoint/2010/main" val="2534821259"/>
+        <p14:creationId xmlns:p14="http://schemas.microsoft.com/office/powerpoint/2010/main" val="4845695"/>
       </p:ext>
     </p:extLst>
   </p:cSld>
@@ -547,7 +547,7 @@
           <p:cNvPr id="2" name="Vertical Title 1">
             <a:extLst>
               <a:ext uri="{FF2B5EF4-FFF2-40B4-BE49-F238E27FC236}">
-                <a16:creationId xmlns:a16="http://schemas.microsoft.com/office/drawing/2014/main" id="{16E186B1-EB81-3C90-A246-72AEFD18FA99}"/>
+                <a16:creationId xmlns:a16="http://schemas.microsoft.com/office/drawing/2014/main" id="{59956CC4-182E-38A9-D1F6-99F2A677AD1C}"/>
               </a:ext>
             </a:extLst>
           </p:cNvPr>
@@ -580,7 +580,7 @@
           <p:cNvPr id="3" name="Vertical Text Placeholder 2">
             <a:extLst>
               <a:ext uri="{FF2B5EF4-FFF2-40B4-BE49-F238E27FC236}">
-                <a16:creationId xmlns:a16="http://schemas.microsoft.com/office/drawing/2014/main" id="{F570E9AB-B859-877C-6F2E-D3086B8528F6}"/>
+                <a16:creationId xmlns:a16="http://schemas.microsoft.com/office/drawing/2014/main" id="{AF2C891B-B838-B557-C23D-00856800A4B1}"/>
               </a:ext>
             </a:extLst>
           </p:cNvPr>
@@ -642,7 +642,7 @@
           <p:cNvPr id="4" name="Date Placeholder 3">
             <a:extLst>
               <a:ext uri="{FF2B5EF4-FFF2-40B4-BE49-F238E27FC236}">
-                <a16:creationId xmlns:a16="http://schemas.microsoft.com/office/drawing/2014/main" id="{CA9A57B5-C2DE-C0AA-AA66-346909390A06}"/>
+                <a16:creationId xmlns:a16="http://schemas.microsoft.com/office/drawing/2014/main" id="{2B8107DB-DAC7-190E-9AA5-0F02421BDDE9}"/>
               </a:ext>
             </a:extLst>
           </p:cNvPr>
@@ -658,7 +658,7 @@
           <a:bodyPr/>
           <a:lstStyle/>
           <a:p>
-            <a:fld id="{E73F329E-F2C3-4FC1-87DF-80EBA0D93720}" type="datetimeFigureOut">
+            <a:fld id="{FD3911C1-3A98-4A4A-AB0A-8F4CBA820BBB}" type="datetimeFigureOut">
               <a:rPr lang="en-US" smtClean="0"/>
               <a:t>5/14/2026</a:t>
             </a:fld>
@@ -671,7 +671,7 @@
           <p:cNvPr id="5" name="Footer Placeholder 4">
             <a:extLst>
               <a:ext uri="{FF2B5EF4-FFF2-40B4-BE49-F238E27FC236}">
-                <a16:creationId xmlns:a16="http://schemas.microsoft.com/office/drawing/2014/main" id="{40528B10-8D23-D119-F992-E25B246B5EAF}"/>
+                <a16:creationId xmlns:a16="http://schemas.microsoft.com/office/drawing/2014/main" id="{337D80D9-32E7-6CDF-F33D-0F736D4F3487}"/>
               </a:ext>
             </a:extLst>
           </p:cNvPr>
@@ -696,7 +696,7 @@
           <p:cNvPr id="6" name="Slide Number Placeholder 5">
             <a:extLst>
               <a:ext uri="{FF2B5EF4-FFF2-40B4-BE49-F238E27FC236}">
-                <a16:creationId xmlns:a16="http://schemas.microsoft.com/office/drawing/2014/main" id="{07DC6EDB-C88A-972D-9106-A89DBC19ED3E}"/>
+                <a16:creationId xmlns:a16="http://schemas.microsoft.com/office/drawing/2014/main" id="{A59DC294-A773-E551-6E04-DEB80A8AD750}"/>
               </a:ext>
             </a:extLst>
           </p:cNvPr>
@@ -712,7 +712,7 @@
           <a:bodyPr/>
           <a:lstStyle/>
           <a:p>
-            <a:fld id="{2A94C4E9-1398-414E-8DBD-9BE78B34AE56}" type="slidenum">
+            <a:fld id="{2A514CDA-1E74-420B-BC3B-A7D966BDE689}" type="slidenum">
               <a:rPr lang="en-US" smtClean="0"/>
               <a:t>‹#›</a:t>
             </a:fld>
@@ -723,7 +723,7 @@
     </p:spTree>
     <p:extLst>
       <p:ext uri="{BB962C8B-B14F-4D97-AF65-F5344CB8AC3E}">
-        <p14:creationId xmlns:p14="http://schemas.microsoft.com/office/powerpoint/2010/main" val="1731294749"/>
+        <p14:creationId xmlns:p14="http://schemas.microsoft.com/office/powerpoint/2010/main" val="2003081261"/>
       </p:ext>
     </p:extLst>
   </p:cSld>
@@ -755,7 +755,7 @@
           <p:cNvPr id="2" name="Title 1">
             <a:extLst>
               <a:ext uri="{FF2B5EF4-FFF2-40B4-BE49-F238E27FC236}">
-                <a16:creationId xmlns:a16="http://schemas.microsoft.com/office/drawing/2014/main" id="{D9EEFEE3-BEC8-A84E-4205-660D7D992181}"/>
+                <a16:creationId xmlns:a16="http://schemas.microsoft.com/office/drawing/2014/main" id="{7F584931-F12D-EDD5-E8D0-7201FA9FBD37}"/>
               </a:ext>
             </a:extLst>
           </p:cNvPr>
@@ -783,7 +783,7 @@
           <p:cNvPr id="3" name="Content Placeholder 2">
             <a:extLst>
               <a:ext uri="{FF2B5EF4-FFF2-40B4-BE49-F238E27FC236}">
-                <a16:creationId xmlns:a16="http://schemas.microsoft.com/office/drawing/2014/main" id="{2D5FFE00-4620-7B7D-5027-10B772BCD258}"/>
+                <a16:creationId xmlns:a16="http://schemas.microsoft.com/office/drawing/2014/main" id="{99217B77-9C5B-440F-3DFA-4D38F060499B}"/>
               </a:ext>
             </a:extLst>
           </p:cNvPr>
@@ -840,7 +840,7 @@
           <p:cNvPr id="4" name="Date Placeholder 3">
             <a:extLst>
               <a:ext uri="{FF2B5EF4-FFF2-40B4-BE49-F238E27FC236}">
-                <a16:creationId xmlns:a16="http://schemas.microsoft.com/office/drawing/2014/main" id="{260A003B-27D6-AA74-C5BE-07BC0856E3BC}"/>
+                <a16:creationId xmlns:a16="http://schemas.microsoft.com/office/drawing/2014/main" id="{EA809D75-6112-8FE8-F81E-F8E4AA116E90}"/>
               </a:ext>
             </a:extLst>
           </p:cNvPr>
@@ -856,7 +856,7 @@
           <a:bodyPr/>
           <a:lstStyle/>
           <a:p>
-            <a:fld id="{E73F329E-F2C3-4FC1-87DF-80EBA0D93720}" type="datetimeFigureOut">
+            <a:fld id="{FD3911C1-3A98-4A4A-AB0A-8F4CBA820BBB}" type="datetimeFigureOut">
               <a:rPr lang="en-US" smtClean="0"/>
               <a:t>5/14/2026</a:t>
             </a:fld>
@@ -869,7 +869,7 @@
           <p:cNvPr id="5" name="Footer Placeholder 4">
             <a:extLst>
               <a:ext uri="{FF2B5EF4-FFF2-40B4-BE49-F238E27FC236}">
-                <a16:creationId xmlns:a16="http://schemas.microsoft.com/office/drawing/2014/main" id="{B0289967-34A6-6297-4B75-C1735704B313}"/>
+                <a16:creationId xmlns:a16="http://schemas.microsoft.com/office/drawing/2014/main" id="{1165CA04-8B89-467E-3F14-AFD60052C1E8}"/>
               </a:ext>
             </a:extLst>
           </p:cNvPr>
@@ -894,7 +894,7 @@
           <p:cNvPr id="6" name="Slide Number Placeholder 5">
             <a:extLst>
               <a:ext uri="{FF2B5EF4-FFF2-40B4-BE49-F238E27FC236}">
-                <a16:creationId xmlns:a16="http://schemas.microsoft.com/office/drawing/2014/main" id="{5D001C05-161C-D809-FCFF-357E72EE06F7}"/>
+                <a16:creationId xmlns:a16="http://schemas.microsoft.com/office/drawing/2014/main" id="{F77C4925-2208-55A9-690D-2DD470F7BB26}"/>
               </a:ext>
             </a:extLst>
           </p:cNvPr>
@@ -910,7 +910,7 @@
           <a:bodyPr/>
           <a:lstStyle/>
           <a:p>
-            <a:fld id="{2A94C4E9-1398-414E-8DBD-9BE78B34AE56}" type="slidenum">
+            <a:fld id="{2A514CDA-1E74-420B-BC3B-A7D966BDE689}" type="slidenum">
               <a:rPr lang="en-US" smtClean="0"/>
               <a:t>‹#›</a:t>
             </a:fld>
@@ -921,7 +921,7 @@
     </p:spTree>
     <p:extLst>
       <p:ext uri="{BB962C8B-B14F-4D97-AF65-F5344CB8AC3E}">
-        <p14:creationId xmlns:p14="http://schemas.microsoft.com/office/powerpoint/2010/main" val="3654695102"/>
+        <p14:creationId xmlns:p14="http://schemas.microsoft.com/office/powerpoint/2010/main" val="1858863275"/>
       </p:ext>
     </p:extLst>
   </p:cSld>
@@ -953,7 +953,7 @@
           <p:cNvPr id="2" name="Title 1">
             <a:extLst>
               <a:ext uri="{FF2B5EF4-FFF2-40B4-BE49-F238E27FC236}">
-                <a16:creationId xmlns:a16="http://schemas.microsoft.com/office/drawing/2014/main" id="{D7B6E9D3-48D3-336C-9660-5242F3CBAB1F}"/>
+                <a16:creationId xmlns:a16="http://schemas.microsoft.com/office/drawing/2014/main" id="{9936095E-62FD-21F6-2E2B-7B17BF53B51F}"/>
               </a:ext>
             </a:extLst>
           </p:cNvPr>
@@ -990,7 +990,7 @@
           <p:cNvPr id="3" name="Text Placeholder 2">
             <a:extLst>
               <a:ext uri="{FF2B5EF4-FFF2-40B4-BE49-F238E27FC236}">
-                <a16:creationId xmlns:a16="http://schemas.microsoft.com/office/drawing/2014/main" id="{DE7C0B91-D1F7-2AF4-CD32-AF624998B9C9}"/>
+                <a16:creationId xmlns:a16="http://schemas.microsoft.com/office/drawing/2014/main" id="{1E47F80F-58F6-1627-B8B4-0818A9143891}"/>
               </a:ext>
             </a:extLst>
           </p:cNvPr>
@@ -1115,7 +1115,7 @@
           <p:cNvPr id="4" name="Date Placeholder 3">
             <a:extLst>
               <a:ext uri="{FF2B5EF4-FFF2-40B4-BE49-F238E27FC236}">
-                <a16:creationId xmlns:a16="http://schemas.microsoft.com/office/drawing/2014/main" id="{65C351B4-C64F-297F-8A51-0ABF10ABD898}"/>
+                <a16:creationId xmlns:a16="http://schemas.microsoft.com/office/drawing/2014/main" id="{5AC4F434-4827-EED1-AFFC-A39180AFCD30}"/>
               </a:ext>
             </a:extLst>
           </p:cNvPr>
@@ -1131,7 +1131,7 @@
           <a:bodyPr/>
           <a:lstStyle/>
           <a:p>
-            <a:fld id="{E73F329E-F2C3-4FC1-87DF-80EBA0D93720}" type="datetimeFigureOut">
+            <a:fld id="{FD3911C1-3A98-4A4A-AB0A-8F4CBA820BBB}" type="datetimeFigureOut">
               <a:rPr lang="en-US" smtClean="0"/>
               <a:t>5/14/2026</a:t>
             </a:fld>
@@ -1144,7 +1144,7 @@
           <p:cNvPr id="5" name="Footer Placeholder 4">
             <a:extLst>
               <a:ext uri="{FF2B5EF4-FFF2-40B4-BE49-F238E27FC236}">
-                <a16:creationId xmlns:a16="http://schemas.microsoft.com/office/drawing/2014/main" id="{18BB27BA-29CE-5C33-F867-87D918604793}"/>
+                <a16:creationId xmlns:a16="http://schemas.microsoft.com/office/drawing/2014/main" id="{721BAB19-FBBD-BECE-DD36-9B09024069DA}"/>
               </a:ext>
             </a:extLst>
           </p:cNvPr>
@@ -1169,7 +1169,7 @@
           <p:cNvPr id="6" name="Slide Number Placeholder 5">
             <a:extLst>
               <a:ext uri="{FF2B5EF4-FFF2-40B4-BE49-F238E27FC236}">
-                <a16:creationId xmlns:a16="http://schemas.microsoft.com/office/drawing/2014/main" id="{004424C5-C23A-237A-C9CC-BAEE5AFF6449}"/>
+                <a16:creationId xmlns:a16="http://schemas.microsoft.com/office/drawing/2014/main" id="{D5026071-C019-B388-9B20-A627587A444D}"/>
               </a:ext>
             </a:extLst>
           </p:cNvPr>
@@ -1185,7 +1185,7 @@
           <a:bodyPr/>
           <a:lstStyle/>
           <a:p>
-            <a:fld id="{2A94C4E9-1398-414E-8DBD-9BE78B34AE56}" type="slidenum">
+            <a:fld id="{2A514CDA-1E74-420B-BC3B-A7D966BDE689}" type="slidenum">
               <a:rPr lang="en-US" smtClean="0"/>
               <a:t>‹#›</a:t>
             </a:fld>
@@ -1196,7 +1196,7 @@
     </p:spTree>
     <p:extLst>
       <p:ext uri="{BB962C8B-B14F-4D97-AF65-F5344CB8AC3E}">
-        <p14:creationId xmlns:p14="http://schemas.microsoft.com/office/powerpoint/2010/main" val="1374089907"/>
+        <p14:creationId xmlns:p14="http://schemas.microsoft.com/office/powerpoint/2010/main" val="3805601201"/>
       </p:ext>
     </p:extLst>
   </p:cSld>
@@ -1228,7 +1228,7 @@
           <p:cNvPr id="2" name="Title 1">
             <a:extLst>
               <a:ext uri="{FF2B5EF4-FFF2-40B4-BE49-F238E27FC236}">
-                <a16:creationId xmlns:a16="http://schemas.microsoft.com/office/drawing/2014/main" id="{B9F7EC26-3DA9-03EB-8C4A-99F02AE94BEB}"/>
+                <a16:creationId xmlns:a16="http://schemas.microsoft.com/office/drawing/2014/main" id="{8FE9BCAD-2800-126F-E1E4-253CACC3763E}"/>
               </a:ext>
             </a:extLst>
           </p:cNvPr>
@@ -1256,7 +1256,7 @@
           <p:cNvPr id="3" name="Content Placeholder 2">
             <a:extLst>
               <a:ext uri="{FF2B5EF4-FFF2-40B4-BE49-F238E27FC236}">
-                <a16:creationId xmlns:a16="http://schemas.microsoft.com/office/drawing/2014/main" id="{0C89A024-EF29-3DF4-CEC6-F591FCF55A55}"/>
+                <a16:creationId xmlns:a16="http://schemas.microsoft.com/office/drawing/2014/main" id="{8D588879-87D3-E257-85D8-F947B15B33EA}"/>
               </a:ext>
             </a:extLst>
           </p:cNvPr>
@@ -1318,7 +1318,7 @@
           <p:cNvPr id="4" name="Content Placeholder 3">
             <a:extLst>
               <a:ext uri="{FF2B5EF4-FFF2-40B4-BE49-F238E27FC236}">
-                <a16:creationId xmlns:a16="http://schemas.microsoft.com/office/drawing/2014/main" id="{2164197F-3EB0-540D-C025-AE22D3322BF1}"/>
+                <a16:creationId xmlns:a16="http://schemas.microsoft.com/office/drawing/2014/main" id="{F2A13909-1D0D-9BF7-BC41-CAD18230BB5E}"/>
               </a:ext>
             </a:extLst>
           </p:cNvPr>
@@ -1380,7 +1380,7 @@
           <p:cNvPr id="5" name="Date Placeholder 4">
             <a:extLst>
               <a:ext uri="{FF2B5EF4-FFF2-40B4-BE49-F238E27FC236}">
-                <a16:creationId xmlns:a16="http://schemas.microsoft.com/office/drawing/2014/main" id="{928CCD08-C1E3-4A5B-827E-9ADE881D4895}"/>
+                <a16:creationId xmlns:a16="http://schemas.microsoft.com/office/drawing/2014/main" id="{360920F5-2570-B826-F8B0-5C68B48175D6}"/>
               </a:ext>
             </a:extLst>
           </p:cNvPr>
@@ -1396,7 +1396,7 @@
           <a:bodyPr/>
           <a:lstStyle/>
           <a:p>
-            <a:fld id="{E73F329E-F2C3-4FC1-87DF-80EBA0D93720}" type="datetimeFigureOut">
+            <a:fld id="{FD3911C1-3A98-4A4A-AB0A-8F4CBA820BBB}" type="datetimeFigureOut">
               <a:rPr lang="en-US" smtClean="0"/>
               <a:t>5/14/2026</a:t>
             </a:fld>
@@ -1409,7 +1409,7 @@
           <p:cNvPr id="6" name="Footer Placeholder 5">
             <a:extLst>
               <a:ext uri="{FF2B5EF4-FFF2-40B4-BE49-F238E27FC236}">
-                <a16:creationId xmlns:a16="http://schemas.microsoft.com/office/drawing/2014/main" id="{959384E3-782C-F04E-E5A5-4EFBF15BECAA}"/>
+                <a16:creationId xmlns:a16="http://schemas.microsoft.com/office/drawing/2014/main" id="{C01DC1CD-3251-DAA0-A9E7-3E6103A3B6CB}"/>
               </a:ext>
             </a:extLst>
           </p:cNvPr>
@@ -1434,7 +1434,7 @@
           <p:cNvPr id="7" name="Slide Number Placeholder 6">
             <a:extLst>
               <a:ext uri="{FF2B5EF4-FFF2-40B4-BE49-F238E27FC236}">
-                <a16:creationId xmlns:a16="http://schemas.microsoft.com/office/drawing/2014/main" id="{04BF2692-8708-A136-DA5B-56F77575A976}"/>
+                <a16:creationId xmlns:a16="http://schemas.microsoft.com/office/drawing/2014/main" id="{01DDC890-65C0-851F-E149-E423DF239860}"/>
               </a:ext>
             </a:extLst>
           </p:cNvPr>
@@ -1450,7 +1450,7 @@
           <a:bodyPr/>
           <a:lstStyle/>
           <a:p>
-            <a:fld id="{2A94C4E9-1398-414E-8DBD-9BE78B34AE56}" type="slidenum">
+            <a:fld id="{2A514CDA-1E74-420B-BC3B-A7D966BDE689}" type="slidenum">
               <a:rPr lang="en-US" smtClean="0"/>
               <a:t>‹#›</a:t>
             </a:fld>
@@ -1461,7 +1461,7 @@
     </p:spTree>
     <p:extLst>
       <p:ext uri="{BB962C8B-B14F-4D97-AF65-F5344CB8AC3E}">
-        <p14:creationId xmlns:p14="http://schemas.microsoft.com/office/powerpoint/2010/main" val="3595099324"/>
+        <p14:creationId xmlns:p14="http://schemas.microsoft.com/office/powerpoint/2010/main" val="3189305612"/>
       </p:ext>
     </p:extLst>
   </p:cSld>
@@ -1493,7 +1493,7 @@
           <p:cNvPr id="2" name="Title 1">
             <a:extLst>
               <a:ext uri="{FF2B5EF4-FFF2-40B4-BE49-F238E27FC236}">
-                <a16:creationId xmlns:a16="http://schemas.microsoft.com/office/drawing/2014/main" id="{BC2BC8C4-871C-BA4B-9530-106A2917332E}"/>
+                <a16:creationId xmlns:a16="http://schemas.microsoft.com/office/drawing/2014/main" id="{A9A3CE81-2770-9323-9AE9-5E36D667E247}"/>
               </a:ext>
             </a:extLst>
           </p:cNvPr>
@@ -1526,7 +1526,7 @@
           <p:cNvPr id="3" name="Text Placeholder 2">
             <a:extLst>
               <a:ext uri="{FF2B5EF4-FFF2-40B4-BE49-F238E27FC236}">
-                <a16:creationId xmlns:a16="http://schemas.microsoft.com/office/drawing/2014/main" id="{E32B2FEB-B45C-9DB7-4493-3857956D463D}"/>
+                <a16:creationId xmlns:a16="http://schemas.microsoft.com/office/drawing/2014/main" id="{5E2037D7-280E-28BA-21FA-0CCF5D46E2B4}"/>
               </a:ext>
             </a:extLst>
           </p:cNvPr>
@@ -1597,7 +1597,7 @@
           <p:cNvPr id="4" name="Content Placeholder 3">
             <a:extLst>
               <a:ext uri="{FF2B5EF4-FFF2-40B4-BE49-F238E27FC236}">
-                <a16:creationId xmlns:a16="http://schemas.microsoft.com/office/drawing/2014/main" id="{DD12921F-1D84-1320-048C-B807E1464166}"/>
+                <a16:creationId xmlns:a16="http://schemas.microsoft.com/office/drawing/2014/main" id="{D9E85550-EA6C-1031-62B9-AB8C309374AC}"/>
               </a:ext>
             </a:extLst>
           </p:cNvPr>
@@ -1659,7 +1659,7 @@
           <p:cNvPr id="5" name="Text Placeholder 4">
             <a:extLst>
               <a:ext uri="{FF2B5EF4-FFF2-40B4-BE49-F238E27FC236}">
-                <a16:creationId xmlns:a16="http://schemas.microsoft.com/office/drawing/2014/main" id="{D1D7906E-D707-FB22-B7D4-5EFD073B6852}"/>
+                <a16:creationId xmlns:a16="http://schemas.microsoft.com/office/drawing/2014/main" id="{70C65EED-A775-21A9-3292-FC264D76DFF0}"/>
               </a:ext>
             </a:extLst>
           </p:cNvPr>
@@ -1730,7 +1730,7 @@
           <p:cNvPr id="6" name="Content Placeholder 5">
             <a:extLst>
               <a:ext uri="{FF2B5EF4-FFF2-40B4-BE49-F238E27FC236}">
-                <a16:creationId xmlns:a16="http://schemas.microsoft.com/office/drawing/2014/main" id="{CCCAFA31-87C0-E536-0672-55E9BA15FA49}"/>
+                <a16:creationId xmlns:a16="http://schemas.microsoft.com/office/drawing/2014/main" id="{12D3E6ED-0718-013B-ACFC-6429EF9D577C}"/>
               </a:ext>
             </a:extLst>
           </p:cNvPr>
@@ -1792,7 +1792,7 @@
           <p:cNvPr id="7" name="Date Placeholder 6">
             <a:extLst>
               <a:ext uri="{FF2B5EF4-FFF2-40B4-BE49-F238E27FC236}">
-                <a16:creationId xmlns:a16="http://schemas.microsoft.com/office/drawing/2014/main" id="{1CFAA9E5-942F-FEEF-105E-E309F69B80E4}"/>
+                <a16:creationId xmlns:a16="http://schemas.microsoft.com/office/drawing/2014/main" id="{D852495D-6747-2BB4-49EA-79DF8BC1940A}"/>
               </a:ext>
             </a:extLst>
           </p:cNvPr>
@@ -1808,7 +1808,7 @@
           <a:bodyPr/>
           <a:lstStyle/>
           <a:p>
-            <a:fld id="{E73F329E-F2C3-4FC1-87DF-80EBA0D93720}" type="datetimeFigureOut">
+            <a:fld id="{FD3911C1-3A98-4A4A-AB0A-8F4CBA820BBB}" type="datetimeFigureOut">
               <a:rPr lang="en-US" smtClean="0"/>
               <a:t>5/14/2026</a:t>
             </a:fld>
@@ -1821,7 +1821,7 @@
           <p:cNvPr id="8" name="Footer Placeholder 7">
             <a:extLst>
               <a:ext uri="{FF2B5EF4-FFF2-40B4-BE49-F238E27FC236}">
-                <a16:creationId xmlns:a16="http://schemas.microsoft.com/office/drawing/2014/main" id="{27C06E8F-5A23-E3C3-ED03-24C4D9F9542E}"/>
+                <a16:creationId xmlns:a16="http://schemas.microsoft.com/office/drawing/2014/main" id="{FC183E17-9366-C5A5-5FA5-9962BB2E5F81}"/>
               </a:ext>
             </a:extLst>
           </p:cNvPr>
@@ -1846,7 +1846,7 @@
           <p:cNvPr id="9" name="Slide Number Placeholder 8">
             <a:extLst>
               <a:ext uri="{FF2B5EF4-FFF2-40B4-BE49-F238E27FC236}">
-                <a16:creationId xmlns:a16="http://schemas.microsoft.com/office/drawing/2014/main" id="{0BC2CD46-28E9-940A-B9F7-AB8FDB2C0A2E}"/>
+                <a16:creationId xmlns:a16="http://schemas.microsoft.com/office/drawing/2014/main" id="{FA4DCCF7-F424-BEEE-DB92-B74D6C504830}"/>
               </a:ext>
             </a:extLst>
           </p:cNvPr>
@@ -1862,7 +1862,7 @@
           <a:bodyPr/>
           <a:lstStyle/>
           <a:p>
-            <a:fld id="{2A94C4E9-1398-414E-8DBD-9BE78B34AE56}" type="slidenum">
+            <a:fld id="{2A514CDA-1E74-420B-BC3B-A7D966BDE689}" type="slidenum">
               <a:rPr lang="en-US" smtClean="0"/>
               <a:t>‹#›</a:t>
             </a:fld>
@@ -1873,7 +1873,7 @@
     </p:spTree>
     <p:extLst>
       <p:ext uri="{BB962C8B-B14F-4D97-AF65-F5344CB8AC3E}">
-        <p14:creationId xmlns:p14="http://schemas.microsoft.com/office/powerpoint/2010/main" val="3639362545"/>
+        <p14:creationId xmlns:p14="http://schemas.microsoft.com/office/powerpoint/2010/main" val="259401496"/>
       </p:ext>
     </p:extLst>
   </p:cSld>
@@ -1905,7 +1905,7 @@
           <p:cNvPr id="2" name="Title 1">
             <a:extLst>
               <a:ext uri="{FF2B5EF4-FFF2-40B4-BE49-F238E27FC236}">
-                <a16:creationId xmlns:a16="http://schemas.microsoft.com/office/drawing/2014/main" id="{9139E3F1-4922-4CA9-EA2F-D67DCCADA0D0}"/>
+                <a16:creationId xmlns:a16="http://schemas.microsoft.com/office/drawing/2014/main" id="{2E988770-0121-E8C1-D515-812D2A094E97}"/>
               </a:ext>
             </a:extLst>
           </p:cNvPr>
@@ -1933,7 +1933,7 @@
           <p:cNvPr id="3" name="Date Placeholder 2">
             <a:extLst>
               <a:ext uri="{FF2B5EF4-FFF2-40B4-BE49-F238E27FC236}">
-                <a16:creationId xmlns:a16="http://schemas.microsoft.com/office/drawing/2014/main" id="{8CE1983F-6FDC-E8BF-0340-3E9E729AA7DB}"/>
+                <a16:creationId xmlns:a16="http://schemas.microsoft.com/office/drawing/2014/main" id="{6027B6E6-7B1A-3C2A-4775-7C8B32E7589D}"/>
               </a:ext>
             </a:extLst>
           </p:cNvPr>
@@ -1949,7 +1949,7 @@
           <a:bodyPr/>
           <a:lstStyle/>
           <a:p>
-            <a:fld id="{E73F329E-F2C3-4FC1-87DF-80EBA0D93720}" type="datetimeFigureOut">
+            <a:fld id="{FD3911C1-3A98-4A4A-AB0A-8F4CBA820BBB}" type="datetimeFigureOut">
               <a:rPr lang="en-US" smtClean="0"/>
               <a:t>5/14/2026</a:t>
             </a:fld>
@@ -1962,7 +1962,7 @@
           <p:cNvPr id="4" name="Footer Placeholder 3">
             <a:extLst>
               <a:ext uri="{FF2B5EF4-FFF2-40B4-BE49-F238E27FC236}">
-                <a16:creationId xmlns:a16="http://schemas.microsoft.com/office/drawing/2014/main" id="{E827DAB2-8392-0F51-328D-76C6615D217F}"/>
+                <a16:creationId xmlns:a16="http://schemas.microsoft.com/office/drawing/2014/main" id="{5409056E-D293-4451-3C2A-45161077C50E}"/>
               </a:ext>
             </a:extLst>
           </p:cNvPr>
@@ -1987,7 +1987,7 @@
           <p:cNvPr id="5" name="Slide Number Placeholder 4">
             <a:extLst>
               <a:ext uri="{FF2B5EF4-FFF2-40B4-BE49-F238E27FC236}">
-                <a16:creationId xmlns:a16="http://schemas.microsoft.com/office/drawing/2014/main" id="{AFFC0D2B-9CCC-E6DF-BDEA-1A1821FB25F0}"/>
+                <a16:creationId xmlns:a16="http://schemas.microsoft.com/office/drawing/2014/main" id="{83A02062-94D1-71E6-EF00-3D66B4929C66}"/>
               </a:ext>
             </a:extLst>
           </p:cNvPr>
@@ -2003,7 +2003,7 @@
           <a:bodyPr/>
           <a:lstStyle/>
           <a:p>
-            <a:fld id="{2A94C4E9-1398-414E-8DBD-9BE78B34AE56}" type="slidenum">
+            <a:fld id="{2A514CDA-1E74-420B-BC3B-A7D966BDE689}" type="slidenum">
               <a:rPr lang="en-US" smtClean="0"/>
               <a:t>‹#›</a:t>
             </a:fld>
@@ -2014,7 +2014,7 @@
     </p:spTree>
     <p:extLst>
       <p:ext uri="{BB962C8B-B14F-4D97-AF65-F5344CB8AC3E}">
-        <p14:creationId xmlns:p14="http://schemas.microsoft.com/office/powerpoint/2010/main" val="720463237"/>
+        <p14:creationId xmlns:p14="http://schemas.microsoft.com/office/powerpoint/2010/main" val="703415452"/>
       </p:ext>
     </p:extLst>
   </p:cSld>
@@ -2046,7 +2046,7 @@
           <p:cNvPr id="2" name="Date Placeholder 1">
             <a:extLst>
               <a:ext uri="{FF2B5EF4-FFF2-40B4-BE49-F238E27FC236}">
-                <a16:creationId xmlns:a16="http://schemas.microsoft.com/office/drawing/2014/main" id="{2FB11C26-8167-0453-E79B-A949EBF5E606}"/>
+                <a16:creationId xmlns:a16="http://schemas.microsoft.com/office/drawing/2014/main" id="{EDA475D4-B511-5DA8-6AA5-9D4F079067E7}"/>
               </a:ext>
             </a:extLst>
           </p:cNvPr>
@@ -2062,7 +2062,7 @@
           <a:bodyPr/>
           <a:lstStyle/>
           <a:p>
-            <a:fld id="{E73F329E-F2C3-4FC1-87DF-80EBA0D93720}" type="datetimeFigureOut">
+            <a:fld id="{FD3911C1-3A98-4A4A-AB0A-8F4CBA820BBB}" type="datetimeFigureOut">
               <a:rPr lang="en-US" smtClean="0"/>
               <a:t>5/14/2026</a:t>
             </a:fld>
@@ -2075,7 +2075,7 @@
           <p:cNvPr id="3" name="Footer Placeholder 2">
             <a:extLst>
               <a:ext uri="{FF2B5EF4-FFF2-40B4-BE49-F238E27FC236}">
-                <a16:creationId xmlns:a16="http://schemas.microsoft.com/office/drawing/2014/main" id="{2808F2AE-F08F-AF0A-FB41-28FF2B9E69EC}"/>
+                <a16:creationId xmlns:a16="http://schemas.microsoft.com/office/drawing/2014/main" id="{6D3C8573-E078-9FA0-2CC7-05B35B0A308D}"/>
               </a:ext>
             </a:extLst>
           </p:cNvPr>
@@ -2100,7 +2100,7 @@
           <p:cNvPr id="4" name="Slide Number Placeholder 3">
             <a:extLst>
               <a:ext uri="{FF2B5EF4-FFF2-40B4-BE49-F238E27FC236}">
-                <a16:creationId xmlns:a16="http://schemas.microsoft.com/office/drawing/2014/main" id="{73016109-CDF2-20AA-FF64-A46115FAD4FA}"/>
+                <a16:creationId xmlns:a16="http://schemas.microsoft.com/office/drawing/2014/main" id="{4B3762DF-C334-C877-5A32-D91C89A73220}"/>
               </a:ext>
             </a:extLst>
           </p:cNvPr>
@@ -2116,7 +2116,7 @@
           <a:bodyPr/>
           <a:lstStyle/>
           <a:p>
-            <a:fld id="{2A94C4E9-1398-414E-8DBD-9BE78B34AE56}" type="slidenum">
+            <a:fld id="{2A514CDA-1E74-420B-BC3B-A7D966BDE689}" type="slidenum">
               <a:rPr lang="en-US" smtClean="0"/>
               <a:t>‹#›</a:t>
             </a:fld>
@@ -2127,7 +2127,7 @@
     </p:spTree>
     <p:extLst>
       <p:ext uri="{BB962C8B-B14F-4D97-AF65-F5344CB8AC3E}">
-        <p14:creationId xmlns:p14="http://schemas.microsoft.com/office/powerpoint/2010/main" val="1201344318"/>
+        <p14:creationId xmlns:p14="http://schemas.microsoft.com/office/powerpoint/2010/main" val="3559940661"/>
       </p:ext>
     </p:extLst>
   </p:cSld>
@@ -2159,7 +2159,7 @@
           <p:cNvPr id="2" name="Title 1">
             <a:extLst>
               <a:ext uri="{FF2B5EF4-FFF2-40B4-BE49-F238E27FC236}">
-                <a16:creationId xmlns:a16="http://schemas.microsoft.com/office/drawing/2014/main" id="{84841FC1-19A6-ABEE-009A-B4852CC6E6AD}"/>
+                <a16:creationId xmlns:a16="http://schemas.microsoft.com/office/drawing/2014/main" id="{5B6A98CE-20D1-FB28-F54B-41F1F3FF9404}"/>
               </a:ext>
             </a:extLst>
           </p:cNvPr>
@@ -2196,7 +2196,7 @@
           <p:cNvPr id="3" name="Content Placeholder 2">
             <a:extLst>
               <a:ext uri="{FF2B5EF4-FFF2-40B4-BE49-F238E27FC236}">
-                <a16:creationId xmlns:a16="http://schemas.microsoft.com/office/drawing/2014/main" id="{F2CF420F-FB47-29B0-AA37-125117B09326}"/>
+                <a16:creationId xmlns:a16="http://schemas.microsoft.com/office/drawing/2014/main" id="{FEA9A833-7679-D0E4-2009-2E311983502A}"/>
               </a:ext>
             </a:extLst>
           </p:cNvPr>
@@ -2286,7 +2286,7 @@
           <p:cNvPr id="4" name="Text Placeholder 3">
             <a:extLst>
               <a:ext uri="{FF2B5EF4-FFF2-40B4-BE49-F238E27FC236}">
-                <a16:creationId xmlns:a16="http://schemas.microsoft.com/office/drawing/2014/main" id="{5052B021-9888-8A3E-E03E-9CD8B0CEA5AD}"/>
+                <a16:creationId xmlns:a16="http://schemas.microsoft.com/office/drawing/2014/main" id="{063C0431-B3CE-A85F-9F10-C60EFF94EE60}"/>
               </a:ext>
             </a:extLst>
           </p:cNvPr>
@@ -2357,7 +2357,7 @@
           <p:cNvPr id="5" name="Date Placeholder 4">
             <a:extLst>
               <a:ext uri="{FF2B5EF4-FFF2-40B4-BE49-F238E27FC236}">
-                <a16:creationId xmlns:a16="http://schemas.microsoft.com/office/drawing/2014/main" id="{CFF13F25-C636-8929-8819-8FFD8A27A014}"/>
+                <a16:creationId xmlns:a16="http://schemas.microsoft.com/office/drawing/2014/main" id="{2606073F-B7BE-532E-9630-FDA339526353}"/>
               </a:ext>
             </a:extLst>
           </p:cNvPr>
@@ -2373,7 +2373,7 @@
           <a:bodyPr/>
           <a:lstStyle/>
           <a:p>
-            <a:fld id="{E73F329E-F2C3-4FC1-87DF-80EBA0D93720}" type="datetimeFigureOut">
+            <a:fld id="{FD3911C1-3A98-4A4A-AB0A-8F4CBA820BBB}" type="datetimeFigureOut">
               <a:rPr lang="en-US" smtClean="0"/>
               <a:t>5/14/2026</a:t>
             </a:fld>
@@ -2386,7 +2386,7 @@
           <p:cNvPr id="6" name="Footer Placeholder 5">
             <a:extLst>
               <a:ext uri="{FF2B5EF4-FFF2-40B4-BE49-F238E27FC236}">
-                <a16:creationId xmlns:a16="http://schemas.microsoft.com/office/drawing/2014/main" id="{CE37CF3A-C418-79C9-ED07-2F172F459D3A}"/>
+                <a16:creationId xmlns:a16="http://schemas.microsoft.com/office/drawing/2014/main" id="{E30F1D0B-26A2-A37F-A86D-75E70F784349}"/>
               </a:ext>
             </a:extLst>
           </p:cNvPr>
@@ -2411,7 +2411,7 @@
           <p:cNvPr id="7" name="Slide Number Placeholder 6">
             <a:extLst>
               <a:ext uri="{FF2B5EF4-FFF2-40B4-BE49-F238E27FC236}">
-                <a16:creationId xmlns:a16="http://schemas.microsoft.com/office/drawing/2014/main" id="{1D5D4368-5566-2FD8-4C7F-8FBDA1155535}"/>
+                <a16:creationId xmlns:a16="http://schemas.microsoft.com/office/drawing/2014/main" id="{E83B46B1-1FA2-C9DA-B78E-6CAFD4F8EDFD}"/>
               </a:ext>
             </a:extLst>
           </p:cNvPr>
@@ -2427,7 +2427,7 @@
           <a:bodyPr/>
           <a:lstStyle/>
           <a:p>
-            <a:fld id="{2A94C4E9-1398-414E-8DBD-9BE78B34AE56}" type="slidenum">
+            <a:fld id="{2A514CDA-1E74-420B-BC3B-A7D966BDE689}" type="slidenum">
               <a:rPr lang="en-US" smtClean="0"/>
               <a:t>‹#›</a:t>
             </a:fld>
@@ -2438,7 +2438,7 @@
     </p:spTree>
     <p:extLst>
       <p:ext uri="{BB962C8B-B14F-4D97-AF65-F5344CB8AC3E}">
-        <p14:creationId xmlns:p14="http://schemas.microsoft.com/office/powerpoint/2010/main" val="3053541135"/>
+        <p14:creationId xmlns:p14="http://schemas.microsoft.com/office/powerpoint/2010/main" val="1375399903"/>
       </p:ext>
     </p:extLst>
   </p:cSld>
@@ -2470,7 +2470,7 @@
           <p:cNvPr id="2" name="Title 1">
             <a:extLst>
               <a:ext uri="{FF2B5EF4-FFF2-40B4-BE49-F238E27FC236}">
-                <a16:creationId xmlns:a16="http://schemas.microsoft.com/office/drawing/2014/main" id="{5EF74C55-0D5A-006B-14D2-34C6F8EE850C}"/>
+                <a16:creationId xmlns:a16="http://schemas.microsoft.com/office/drawing/2014/main" id="{7C39DEAD-5E6F-BC6D-F715-7905FFA7A1C1}"/>
               </a:ext>
             </a:extLst>
           </p:cNvPr>
@@ -2507,7 +2507,7 @@
           <p:cNvPr id="3" name="Picture Placeholder 2">
             <a:extLst>
               <a:ext uri="{FF2B5EF4-FFF2-40B4-BE49-F238E27FC236}">
-                <a16:creationId xmlns:a16="http://schemas.microsoft.com/office/drawing/2014/main" id="{4EF42B3E-00BC-FF7A-8EE4-A26A259ACC83}"/>
+                <a16:creationId xmlns:a16="http://schemas.microsoft.com/office/drawing/2014/main" id="{EAD421E2-AA41-2F78-7AB4-789EF983BC10}"/>
               </a:ext>
             </a:extLst>
           </p:cNvPr>
@@ -2574,7 +2574,7 @@
           <p:cNvPr id="4" name="Text Placeholder 3">
             <a:extLst>
               <a:ext uri="{FF2B5EF4-FFF2-40B4-BE49-F238E27FC236}">
-                <a16:creationId xmlns:a16="http://schemas.microsoft.com/office/drawing/2014/main" id="{A8D8E3CB-93A5-ADBC-D131-F56740D44770}"/>
+                <a16:creationId xmlns:a16="http://schemas.microsoft.com/office/drawing/2014/main" id="{A6E9DAB4-2FB0-8879-113B-2538E68639F6}"/>
               </a:ext>
             </a:extLst>
           </p:cNvPr>
@@ -2645,7 +2645,7 @@
           <p:cNvPr id="5" name="Date Placeholder 4">
             <a:extLst>
               <a:ext uri="{FF2B5EF4-FFF2-40B4-BE49-F238E27FC236}">
-                <a16:creationId xmlns:a16="http://schemas.microsoft.com/office/drawing/2014/main" id="{EDAE3D4A-EC5D-3583-AFF3-BF7FDCC04A93}"/>
+                <a16:creationId xmlns:a16="http://schemas.microsoft.com/office/drawing/2014/main" id="{D58CE92E-F428-2DD4-E1E6-58D4DDCE8FB8}"/>
               </a:ext>
             </a:extLst>
           </p:cNvPr>
@@ -2661,7 +2661,7 @@
           <a:bodyPr/>
           <a:lstStyle/>
           <a:p>
-            <a:fld id="{E73F329E-F2C3-4FC1-87DF-80EBA0D93720}" type="datetimeFigureOut">
+            <a:fld id="{FD3911C1-3A98-4A4A-AB0A-8F4CBA820BBB}" type="datetimeFigureOut">
               <a:rPr lang="en-US" smtClean="0"/>
               <a:t>5/14/2026</a:t>
             </a:fld>
@@ -2674,7 +2674,7 @@
           <p:cNvPr id="6" name="Footer Placeholder 5">
             <a:extLst>
               <a:ext uri="{FF2B5EF4-FFF2-40B4-BE49-F238E27FC236}">
-                <a16:creationId xmlns:a16="http://schemas.microsoft.com/office/drawing/2014/main" id="{ACCBAFF3-F2CC-5485-321F-B132B1C4B459}"/>
+                <a16:creationId xmlns:a16="http://schemas.microsoft.com/office/drawing/2014/main" id="{AE0A778C-4806-DB66-C450-DD961589C84E}"/>
               </a:ext>
             </a:extLst>
           </p:cNvPr>
@@ -2699,7 +2699,7 @@
           <p:cNvPr id="7" name="Slide Number Placeholder 6">
             <a:extLst>
               <a:ext uri="{FF2B5EF4-FFF2-40B4-BE49-F238E27FC236}">
-                <a16:creationId xmlns:a16="http://schemas.microsoft.com/office/drawing/2014/main" id="{6CFC0159-9003-5973-FC91-C705197ADC6E}"/>
+                <a16:creationId xmlns:a16="http://schemas.microsoft.com/office/drawing/2014/main" id="{85A9F7C9-6158-E068-6CBF-4BBBE6116C5E}"/>
               </a:ext>
             </a:extLst>
           </p:cNvPr>
@@ -2715,7 +2715,7 @@
           <a:bodyPr/>
           <a:lstStyle/>
           <a:p>
-            <a:fld id="{2A94C4E9-1398-414E-8DBD-9BE78B34AE56}" type="slidenum">
+            <a:fld id="{2A514CDA-1E74-420B-BC3B-A7D966BDE689}" type="slidenum">
               <a:rPr lang="en-US" smtClean="0"/>
               <a:t>‹#›</a:t>
             </a:fld>
@@ -2726,7 +2726,7 @@
     </p:spTree>
     <p:extLst>
       <p:ext uri="{BB962C8B-B14F-4D97-AF65-F5344CB8AC3E}">
-        <p14:creationId xmlns:p14="http://schemas.microsoft.com/office/powerpoint/2010/main" val="742501255"/>
+        <p14:creationId xmlns:p14="http://schemas.microsoft.com/office/powerpoint/2010/main" val="1455450957"/>
       </p:ext>
     </p:extLst>
   </p:cSld>
@@ -2763,7 +2763,7 @@
           <p:cNvPr id="2" name="Title Placeholder 1">
             <a:extLst>
               <a:ext uri="{FF2B5EF4-FFF2-40B4-BE49-F238E27FC236}">
-                <a16:creationId xmlns:a16="http://schemas.microsoft.com/office/drawing/2014/main" id="{7B1CD31E-8AA9-DD1F-B758-9C42574BD7C5}"/>
+                <a16:creationId xmlns:a16="http://schemas.microsoft.com/office/drawing/2014/main" id="{040BE87B-8B5D-E4C1-3E13-20DD49202BA2}"/>
               </a:ext>
             </a:extLst>
           </p:cNvPr>
@@ -2801,7 +2801,7 @@
           <p:cNvPr id="3" name="Text Placeholder 2">
             <a:extLst>
               <a:ext uri="{FF2B5EF4-FFF2-40B4-BE49-F238E27FC236}">
-                <a16:creationId xmlns:a16="http://schemas.microsoft.com/office/drawing/2014/main" id="{450FB6FD-3669-ECC4-BA05-44D7A4719DA9}"/>
+                <a16:creationId xmlns:a16="http://schemas.microsoft.com/office/drawing/2014/main" id="{259A42AD-27F1-28E8-162B-7662132B8C6F}"/>
               </a:ext>
             </a:extLst>
           </p:cNvPr>
@@ -2868,7 +2868,7 @@
           <p:cNvPr id="4" name="Date Placeholder 3">
             <a:extLst>
               <a:ext uri="{FF2B5EF4-FFF2-40B4-BE49-F238E27FC236}">
-                <a16:creationId xmlns:a16="http://schemas.microsoft.com/office/drawing/2014/main" id="{B51C7BCA-6446-062E-0595-F1D2DF91DDAF}"/>
+                <a16:creationId xmlns:a16="http://schemas.microsoft.com/office/drawing/2014/main" id="{01A85062-32A8-8585-363E-D3B6C519A2B6}"/>
               </a:ext>
             </a:extLst>
           </p:cNvPr>
@@ -2902,7 +2902,7 @@
             </a:lvl1pPr>
           </a:lstStyle>
           <a:p>
-            <a:fld id="{E73F329E-F2C3-4FC1-87DF-80EBA0D93720}" type="datetimeFigureOut">
+            <a:fld id="{FD3911C1-3A98-4A4A-AB0A-8F4CBA820BBB}" type="datetimeFigureOut">
               <a:rPr lang="en-US" smtClean="0"/>
               <a:t>5/14/2026</a:t>
             </a:fld>
@@ -2915,7 +2915,7 @@
           <p:cNvPr id="5" name="Footer Placeholder 4">
             <a:extLst>
               <a:ext uri="{FF2B5EF4-FFF2-40B4-BE49-F238E27FC236}">
-                <a16:creationId xmlns:a16="http://schemas.microsoft.com/office/drawing/2014/main" id="{F626E20D-F31F-FD3F-3D63-51B16DDD51EA}"/>
+                <a16:creationId xmlns:a16="http://schemas.microsoft.com/office/drawing/2014/main" id="{1A8B5B07-097C-6480-BD78-4CB0DA7B2343}"/>
               </a:ext>
             </a:extLst>
           </p:cNvPr>
@@ -2958,7 +2958,7 @@
           <p:cNvPr id="6" name="Slide Number Placeholder 5">
             <a:extLst>
               <a:ext uri="{FF2B5EF4-FFF2-40B4-BE49-F238E27FC236}">
-                <a16:creationId xmlns:a16="http://schemas.microsoft.com/office/drawing/2014/main" id="{690B11AD-D580-E68E-AA56-B989036C75F4}"/>
+                <a16:creationId xmlns:a16="http://schemas.microsoft.com/office/drawing/2014/main" id="{549E8EB9-8547-C00C-D465-884E0CD53F02}"/>
               </a:ext>
             </a:extLst>
           </p:cNvPr>
@@ -2992,7 +2992,7 @@
             </a:lvl1pPr>
           </a:lstStyle>
           <a:p>
-            <a:fld id="{2A94C4E9-1398-414E-8DBD-9BE78B34AE56}" type="slidenum">
+            <a:fld id="{2A514CDA-1E74-420B-BC3B-A7D966BDE689}" type="slidenum">
               <a:rPr lang="en-US" smtClean="0"/>
               <a:t>‹#›</a:t>
             </a:fld>
@@ -3003,7 +3003,7 @@
     </p:spTree>
     <p:extLst>
       <p:ext uri="{BB962C8B-B14F-4D97-AF65-F5344CB8AC3E}">
-        <p14:creationId xmlns:p14="http://schemas.microsoft.com/office/powerpoint/2010/main" val="1933630819"/>
+        <p14:creationId xmlns:p14="http://schemas.microsoft.com/office/powerpoint/2010/main" val="1208790470"/>
       </p:ext>
     </p:extLst>
   </p:cSld>
@@ -3324,7 +3324,7 @@
     </p:spTree>
     <p:extLst>
       <p:ext uri="{BB962C8B-B14F-4D97-AF65-F5344CB8AC3E}">
-        <p14:creationId xmlns:p14="http://schemas.microsoft.com/office/powerpoint/2010/main" val="378130769"/>
+        <p14:creationId xmlns:p14="http://schemas.microsoft.com/office/powerpoint/2010/main" val="288382371"/>
       </p:ext>
     </p:extLst>
   </p:cSld>

</xml_diff>

<commit_message>
Add PPTX image visual case
</commit_message>
<xml_diff>
--- a/tests/Lokad.OoxPdf.Tests/Cases/pptx-blank.pptx
+++ b/tests/Lokad.OoxPdf.Tests/Cases/pptx-blank.pptx
@@ -129,7 +129,7 @@
           <p:cNvPr id="2" name="Title 1">
             <a:extLst>
               <a:ext uri="{FF2B5EF4-FFF2-40B4-BE49-F238E27FC236}">
-                <a16:creationId xmlns:a16="http://schemas.microsoft.com/office/drawing/2014/main" id="{94CD72B9-FF87-ACA7-B12B-134C268890D3}"/>
+                <a16:creationId xmlns:a16="http://schemas.microsoft.com/office/drawing/2014/main" id="{3DEB7B8E-0652-6B22-1462-32F92CDA1979}"/>
               </a:ext>
             </a:extLst>
           </p:cNvPr>
@@ -166,7 +166,7 @@
           <p:cNvPr id="3" name="Subtitle 2">
             <a:extLst>
               <a:ext uri="{FF2B5EF4-FFF2-40B4-BE49-F238E27FC236}">
-                <a16:creationId xmlns:a16="http://schemas.microsoft.com/office/drawing/2014/main" id="{F253B2CF-A452-0A98-0F9C-CC3EBE15BF06}"/>
+                <a16:creationId xmlns:a16="http://schemas.microsoft.com/office/drawing/2014/main" id="{D9778783-1D10-7623-7AAF-CA41CF37C7FC}"/>
               </a:ext>
             </a:extLst>
           </p:cNvPr>
@@ -236,7 +236,7 @@
           <p:cNvPr id="4" name="Date Placeholder 3">
             <a:extLst>
               <a:ext uri="{FF2B5EF4-FFF2-40B4-BE49-F238E27FC236}">
-                <a16:creationId xmlns:a16="http://schemas.microsoft.com/office/drawing/2014/main" id="{BFD59B7F-CC80-D389-B8EF-0097B6FE365F}"/>
+                <a16:creationId xmlns:a16="http://schemas.microsoft.com/office/drawing/2014/main" id="{7643F9FD-56AB-C26D-0DC0-4B469F1474CF}"/>
               </a:ext>
             </a:extLst>
           </p:cNvPr>
@@ -252,7 +252,7 @@
           <a:bodyPr/>
           <a:lstStyle/>
           <a:p>
-            <a:fld id="{FD3911C1-3A98-4A4A-AB0A-8F4CBA820BBB}" type="datetimeFigureOut">
+            <a:fld id="{0D6085B6-32CC-41D7-BE48-8EC3E5D75128}" type="datetimeFigureOut">
               <a:rPr lang="en-US" smtClean="0"/>
               <a:t>5/14/2026</a:t>
             </a:fld>
@@ -265,7 +265,7 @@
           <p:cNvPr id="5" name="Footer Placeholder 4">
             <a:extLst>
               <a:ext uri="{FF2B5EF4-FFF2-40B4-BE49-F238E27FC236}">
-                <a16:creationId xmlns:a16="http://schemas.microsoft.com/office/drawing/2014/main" id="{684E87BB-BC04-4B62-E177-16DE3E47D34C}"/>
+                <a16:creationId xmlns:a16="http://schemas.microsoft.com/office/drawing/2014/main" id="{67D0748D-8335-6BA6-2FF0-FD52E8382B14}"/>
               </a:ext>
             </a:extLst>
           </p:cNvPr>
@@ -290,7 +290,7 @@
           <p:cNvPr id="6" name="Slide Number Placeholder 5">
             <a:extLst>
               <a:ext uri="{FF2B5EF4-FFF2-40B4-BE49-F238E27FC236}">
-                <a16:creationId xmlns:a16="http://schemas.microsoft.com/office/drawing/2014/main" id="{A7A4EC9C-321D-1E5A-4B07-E6FEF4571BEC}"/>
+                <a16:creationId xmlns:a16="http://schemas.microsoft.com/office/drawing/2014/main" id="{FC635EE4-33B6-6BA1-5E1D-B5537072DCEB}"/>
               </a:ext>
             </a:extLst>
           </p:cNvPr>
@@ -306,7 +306,7 @@
           <a:bodyPr/>
           <a:lstStyle/>
           <a:p>
-            <a:fld id="{2A514CDA-1E74-420B-BC3B-A7D966BDE689}" type="slidenum">
+            <a:fld id="{9710AAFE-4C88-4438-AE64-610A72457F90}" type="slidenum">
               <a:rPr lang="en-US" smtClean="0"/>
               <a:t>‹#›</a:t>
             </a:fld>
@@ -317,7 +317,7 @@
     </p:spTree>
     <p:extLst>
       <p:ext uri="{BB962C8B-B14F-4D97-AF65-F5344CB8AC3E}">
-        <p14:creationId xmlns:p14="http://schemas.microsoft.com/office/powerpoint/2010/main" val="340045867"/>
+        <p14:creationId xmlns:p14="http://schemas.microsoft.com/office/powerpoint/2010/main" val="1229990530"/>
       </p:ext>
     </p:extLst>
   </p:cSld>
@@ -349,7 +349,7 @@
           <p:cNvPr id="2" name="Title 1">
             <a:extLst>
               <a:ext uri="{FF2B5EF4-FFF2-40B4-BE49-F238E27FC236}">
-                <a16:creationId xmlns:a16="http://schemas.microsoft.com/office/drawing/2014/main" id="{75657439-1DD1-31D9-E6C8-06D3293C99CB}"/>
+                <a16:creationId xmlns:a16="http://schemas.microsoft.com/office/drawing/2014/main" id="{7123EE6A-FE40-E8D9-FDF4-E4DB9EAB5856}"/>
               </a:ext>
             </a:extLst>
           </p:cNvPr>
@@ -377,7 +377,7 @@
           <p:cNvPr id="3" name="Vertical Text Placeholder 2">
             <a:extLst>
               <a:ext uri="{FF2B5EF4-FFF2-40B4-BE49-F238E27FC236}">
-                <a16:creationId xmlns:a16="http://schemas.microsoft.com/office/drawing/2014/main" id="{AB7A188A-9B1D-9826-9BA5-748DEF7DAF9B}"/>
+                <a16:creationId xmlns:a16="http://schemas.microsoft.com/office/drawing/2014/main" id="{6F810C76-CDE9-8E80-3224-D24B8E2C991B}"/>
               </a:ext>
             </a:extLst>
           </p:cNvPr>
@@ -434,7 +434,7 @@
           <p:cNvPr id="4" name="Date Placeholder 3">
             <a:extLst>
               <a:ext uri="{FF2B5EF4-FFF2-40B4-BE49-F238E27FC236}">
-                <a16:creationId xmlns:a16="http://schemas.microsoft.com/office/drawing/2014/main" id="{3541695A-F3B9-4952-C817-1D2A7D6B23B7}"/>
+                <a16:creationId xmlns:a16="http://schemas.microsoft.com/office/drawing/2014/main" id="{15F43D8D-4670-5E7E-2411-D34C8282F1CB}"/>
               </a:ext>
             </a:extLst>
           </p:cNvPr>
@@ -450,7 +450,7 @@
           <a:bodyPr/>
           <a:lstStyle/>
           <a:p>
-            <a:fld id="{FD3911C1-3A98-4A4A-AB0A-8F4CBA820BBB}" type="datetimeFigureOut">
+            <a:fld id="{0D6085B6-32CC-41D7-BE48-8EC3E5D75128}" type="datetimeFigureOut">
               <a:rPr lang="en-US" smtClean="0"/>
               <a:t>5/14/2026</a:t>
             </a:fld>
@@ -463,7 +463,7 @@
           <p:cNvPr id="5" name="Footer Placeholder 4">
             <a:extLst>
               <a:ext uri="{FF2B5EF4-FFF2-40B4-BE49-F238E27FC236}">
-                <a16:creationId xmlns:a16="http://schemas.microsoft.com/office/drawing/2014/main" id="{63A88DBC-AAC8-ED1E-9FBA-E3254189ED61}"/>
+                <a16:creationId xmlns:a16="http://schemas.microsoft.com/office/drawing/2014/main" id="{ED84705A-0580-1585-E330-DF353EF05AC8}"/>
               </a:ext>
             </a:extLst>
           </p:cNvPr>
@@ -488,7 +488,7 @@
           <p:cNvPr id="6" name="Slide Number Placeholder 5">
             <a:extLst>
               <a:ext uri="{FF2B5EF4-FFF2-40B4-BE49-F238E27FC236}">
-                <a16:creationId xmlns:a16="http://schemas.microsoft.com/office/drawing/2014/main" id="{EAA0ABBD-A5EC-295C-0411-CBD6B61FD46E}"/>
+                <a16:creationId xmlns:a16="http://schemas.microsoft.com/office/drawing/2014/main" id="{65962160-5425-680F-EEC9-762FED817356}"/>
               </a:ext>
             </a:extLst>
           </p:cNvPr>
@@ -504,7 +504,7 @@
           <a:bodyPr/>
           <a:lstStyle/>
           <a:p>
-            <a:fld id="{2A514CDA-1E74-420B-BC3B-A7D966BDE689}" type="slidenum">
+            <a:fld id="{9710AAFE-4C88-4438-AE64-610A72457F90}" type="slidenum">
               <a:rPr lang="en-US" smtClean="0"/>
               <a:t>‹#›</a:t>
             </a:fld>
@@ -515,7 +515,7 @@
     </p:spTree>
     <p:extLst>
       <p:ext uri="{BB962C8B-B14F-4D97-AF65-F5344CB8AC3E}">
-        <p14:creationId xmlns:p14="http://schemas.microsoft.com/office/powerpoint/2010/main" val="4845695"/>
+        <p14:creationId xmlns:p14="http://schemas.microsoft.com/office/powerpoint/2010/main" val="769975556"/>
       </p:ext>
     </p:extLst>
   </p:cSld>
@@ -547,7 +547,7 @@
           <p:cNvPr id="2" name="Vertical Title 1">
             <a:extLst>
               <a:ext uri="{FF2B5EF4-FFF2-40B4-BE49-F238E27FC236}">
-                <a16:creationId xmlns:a16="http://schemas.microsoft.com/office/drawing/2014/main" id="{59956CC4-182E-38A9-D1F6-99F2A677AD1C}"/>
+                <a16:creationId xmlns:a16="http://schemas.microsoft.com/office/drawing/2014/main" id="{9CDE2B0D-83E3-A6E7-23AE-DF0CEAB8C583}"/>
               </a:ext>
             </a:extLst>
           </p:cNvPr>
@@ -580,7 +580,7 @@
           <p:cNvPr id="3" name="Vertical Text Placeholder 2">
             <a:extLst>
               <a:ext uri="{FF2B5EF4-FFF2-40B4-BE49-F238E27FC236}">
-                <a16:creationId xmlns:a16="http://schemas.microsoft.com/office/drawing/2014/main" id="{AF2C891B-B838-B557-C23D-00856800A4B1}"/>
+                <a16:creationId xmlns:a16="http://schemas.microsoft.com/office/drawing/2014/main" id="{FA18569B-C427-15B9-A857-C311912FCCE0}"/>
               </a:ext>
             </a:extLst>
           </p:cNvPr>
@@ -642,7 +642,7 @@
           <p:cNvPr id="4" name="Date Placeholder 3">
             <a:extLst>
               <a:ext uri="{FF2B5EF4-FFF2-40B4-BE49-F238E27FC236}">
-                <a16:creationId xmlns:a16="http://schemas.microsoft.com/office/drawing/2014/main" id="{2B8107DB-DAC7-190E-9AA5-0F02421BDDE9}"/>
+                <a16:creationId xmlns:a16="http://schemas.microsoft.com/office/drawing/2014/main" id="{12455272-23B3-98D0-C2D3-4E35378ACE9A}"/>
               </a:ext>
             </a:extLst>
           </p:cNvPr>
@@ -658,7 +658,7 @@
           <a:bodyPr/>
           <a:lstStyle/>
           <a:p>
-            <a:fld id="{FD3911C1-3A98-4A4A-AB0A-8F4CBA820BBB}" type="datetimeFigureOut">
+            <a:fld id="{0D6085B6-32CC-41D7-BE48-8EC3E5D75128}" type="datetimeFigureOut">
               <a:rPr lang="en-US" smtClean="0"/>
               <a:t>5/14/2026</a:t>
             </a:fld>
@@ -671,7 +671,7 @@
           <p:cNvPr id="5" name="Footer Placeholder 4">
             <a:extLst>
               <a:ext uri="{FF2B5EF4-FFF2-40B4-BE49-F238E27FC236}">
-                <a16:creationId xmlns:a16="http://schemas.microsoft.com/office/drawing/2014/main" id="{337D80D9-32E7-6CDF-F33D-0F736D4F3487}"/>
+                <a16:creationId xmlns:a16="http://schemas.microsoft.com/office/drawing/2014/main" id="{B9FA7A29-DFF5-20CC-83DA-6655BF2522FE}"/>
               </a:ext>
             </a:extLst>
           </p:cNvPr>
@@ -696,7 +696,7 @@
           <p:cNvPr id="6" name="Slide Number Placeholder 5">
             <a:extLst>
               <a:ext uri="{FF2B5EF4-FFF2-40B4-BE49-F238E27FC236}">
-                <a16:creationId xmlns:a16="http://schemas.microsoft.com/office/drawing/2014/main" id="{A59DC294-A773-E551-6E04-DEB80A8AD750}"/>
+                <a16:creationId xmlns:a16="http://schemas.microsoft.com/office/drawing/2014/main" id="{E19FED60-FB7D-2A40-8F62-D30E9C2A2C99}"/>
               </a:ext>
             </a:extLst>
           </p:cNvPr>
@@ -712,7 +712,7 @@
           <a:bodyPr/>
           <a:lstStyle/>
           <a:p>
-            <a:fld id="{2A514CDA-1E74-420B-BC3B-A7D966BDE689}" type="slidenum">
+            <a:fld id="{9710AAFE-4C88-4438-AE64-610A72457F90}" type="slidenum">
               <a:rPr lang="en-US" smtClean="0"/>
               <a:t>‹#›</a:t>
             </a:fld>
@@ -723,7 +723,7 @@
     </p:spTree>
     <p:extLst>
       <p:ext uri="{BB962C8B-B14F-4D97-AF65-F5344CB8AC3E}">
-        <p14:creationId xmlns:p14="http://schemas.microsoft.com/office/powerpoint/2010/main" val="2003081261"/>
+        <p14:creationId xmlns:p14="http://schemas.microsoft.com/office/powerpoint/2010/main" val="1607249110"/>
       </p:ext>
     </p:extLst>
   </p:cSld>
@@ -755,7 +755,7 @@
           <p:cNvPr id="2" name="Title 1">
             <a:extLst>
               <a:ext uri="{FF2B5EF4-FFF2-40B4-BE49-F238E27FC236}">
-                <a16:creationId xmlns:a16="http://schemas.microsoft.com/office/drawing/2014/main" id="{7F584931-F12D-EDD5-E8D0-7201FA9FBD37}"/>
+                <a16:creationId xmlns:a16="http://schemas.microsoft.com/office/drawing/2014/main" id="{2C683EC5-4ED1-AD11-906B-6D38E6746A32}"/>
               </a:ext>
             </a:extLst>
           </p:cNvPr>
@@ -783,7 +783,7 @@
           <p:cNvPr id="3" name="Content Placeholder 2">
             <a:extLst>
               <a:ext uri="{FF2B5EF4-FFF2-40B4-BE49-F238E27FC236}">
-                <a16:creationId xmlns:a16="http://schemas.microsoft.com/office/drawing/2014/main" id="{99217B77-9C5B-440F-3DFA-4D38F060499B}"/>
+                <a16:creationId xmlns:a16="http://schemas.microsoft.com/office/drawing/2014/main" id="{C886CC59-E003-FC42-B767-F91AB1654B4C}"/>
               </a:ext>
             </a:extLst>
           </p:cNvPr>
@@ -840,7 +840,7 @@
           <p:cNvPr id="4" name="Date Placeholder 3">
             <a:extLst>
               <a:ext uri="{FF2B5EF4-FFF2-40B4-BE49-F238E27FC236}">
-                <a16:creationId xmlns:a16="http://schemas.microsoft.com/office/drawing/2014/main" id="{EA809D75-6112-8FE8-F81E-F8E4AA116E90}"/>
+                <a16:creationId xmlns:a16="http://schemas.microsoft.com/office/drawing/2014/main" id="{5DB1ED93-1DB3-B5F2-35C1-B3903B7DADC6}"/>
               </a:ext>
             </a:extLst>
           </p:cNvPr>
@@ -856,7 +856,7 @@
           <a:bodyPr/>
           <a:lstStyle/>
           <a:p>
-            <a:fld id="{FD3911C1-3A98-4A4A-AB0A-8F4CBA820BBB}" type="datetimeFigureOut">
+            <a:fld id="{0D6085B6-32CC-41D7-BE48-8EC3E5D75128}" type="datetimeFigureOut">
               <a:rPr lang="en-US" smtClean="0"/>
               <a:t>5/14/2026</a:t>
             </a:fld>
@@ -869,7 +869,7 @@
           <p:cNvPr id="5" name="Footer Placeholder 4">
             <a:extLst>
               <a:ext uri="{FF2B5EF4-FFF2-40B4-BE49-F238E27FC236}">
-                <a16:creationId xmlns:a16="http://schemas.microsoft.com/office/drawing/2014/main" id="{1165CA04-8B89-467E-3F14-AFD60052C1E8}"/>
+                <a16:creationId xmlns:a16="http://schemas.microsoft.com/office/drawing/2014/main" id="{3115952F-EDD0-8ABD-E4C7-8B73648B5B62}"/>
               </a:ext>
             </a:extLst>
           </p:cNvPr>
@@ -894,7 +894,7 @@
           <p:cNvPr id="6" name="Slide Number Placeholder 5">
             <a:extLst>
               <a:ext uri="{FF2B5EF4-FFF2-40B4-BE49-F238E27FC236}">
-                <a16:creationId xmlns:a16="http://schemas.microsoft.com/office/drawing/2014/main" id="{F77C4925-2208-55A9-690D-2DD470F7BB26}"/>
+                <a16:creationId xmlns:a16="http://schemas.microsoft.com/office/drawing/2014/main" id="{39C1177C-0102-D084-BC6C-10B2419AEDC2}"/>
               </a:ext>
             </a:extLst>
           </p:cNvPr>
@@ -910,7 +910,7 @@
           <a:bodyPr/>
           <a:lstStyle/>
           <a:p>
-            <a:fld id="{2A514CDA-1E74-420B-BC3B-A7D966BDE689}" type="slidenum">
+            <a:fld id="{9710AAFE-4C88-4438-AE64-610A72457F90}" type="slidenum">
               <a:rPr lang="en-US" smtClean="0"/>
               <a:t>‹#›</a:t>
             </a:fld>
@@ -921,7 +921,7 @@
     </p:spTree>
     <p:extLst>
       <p:ext uri="{BB962C8B-B14F-4D97-AF65-F5344CB8AC3E}">
-        <p14:creationId xmlns:p14="http://schemas.microsoft.com/office/powerpoint/2010/main" val="1858863275"/>
+        <p14:creationId xmlns:p14="http://schemas.microsoft.com/office/powerpoint/2010/main" val="3110223309"/>
       </p:ext>
     </p:extLst>
   </p:cSld>
@@ -953,7 +953,7 @@
           <p:cNvPr id="2" name="Title 1">
             <a:extLst>
               <a:ext uri="{FF2B5EF4-FFF2-40B4-BE49-F238E27FC236}">
-                <a16:creationId xmlns:a16="http://schemas.microsoft.com/office/drawing/2014/main" id="{9936095E-62FD-21F6-2E2B-7B17BF53B51F}"/>
+                <a16:creationId xmlns:a16="http://schemas.microsoft.com/office/drawing/2014/main" id="{7F216C46-0A08-0A5D-FA1D-AD46E3D57A57}"/>
               </a:ext>
             </a:extLst>
           </p:cNvPr>
@@ -990,7 +990,7 @@
           <p:cNvPr id="3" name="Text Placeholder 2">
             <a:extLst>
               <a:ext uri="{FF2B5EF4-FFF2-40B4-BE49-F238E27FC236}">
-                <a16:creationId xmlns:a16="http://schemas.microsoft.com/office/drawing/2014/main" id="{1E47F80F-58F6-1627-B8B4-0818A9143891}"/>
+                <a16:creationId xmlns:a16="http://schemas.microsoft.com/office/drawing/2014/main" id="{F07112AC-06CF-F5B5-9D13-5F163D980DA1}"/>
               </a:ext>
             </a:extLst>
           </p:cNvPr>
@@ -1115,7 +1115,7 @@
           <p:cNvPr id="4" name="Date Placeholder 3">
             <a:extLst>
               <a:ext uri="{FF2B5EF4-FFF2-40B4-BE49-F238E27FC236}">
-                <a16:creationId xmlns:a16="http://schemas.microsoft.com/office/drawing/2014/main" id="{5AC4F434-4827-EED1-AFFC-A39180AFCD30}"/>
+                <a16:creationId xmlns:a16="http://schemas.microsoft.com/office/drawing/2014/main" id="{41B884AF-D263-7159-8FAC-CF89D16520DD}"/>
               </a:ext>
             </a:extLst>
           </p:cNvPr>
@@ -1131,7 +1131,7 @@
           <a:bodyPr/>
           <a:lstStyle/>
           <a:p>
-            <a:fld id="{FD3911C1-3A98-4A4A-AB0A-8F4CBA820BBB}" type="datetimeFigureOut">
+            <a:fld id="{0D6085B6-32CC-41D7-BE48-8EC3E5D75128}" type="datetimeFigureOut">
               <a:rPr lang="en-US" smtClean="0"/>
               <a:t>5/14/2026</a:t>
             </a:fld>
@@ -1144,7 +1144,7 @@
           <p:cNvPr id="5" name="Footer Placeholder 4">
             <a:extLst>
               <a:ext uri="{FF2B5EF4-FFF2-40B4-BE49-F238E27FC236}">
-                <a16:creationId xmlns:a16="http://schemas.microsoft.com/office/drawing/2014/main" id="{721BAB19-FBBD-BECE-DD36-9B09024069DA}"/>
+                <a16:creationId xmlns:a16="http://schemas.microsoft.com/office/drawing/2014/main" id="{5C58DE06-F593-FCF0-A4C5-6DF7D36EFEB3}"/>
               </a:ext>
             </a:extLst>
           </p:cNvPr>
@@ -1169,7 +1169,7 @@
           <p:cNvPr id="6" name="Slide Number Placeholder 5">
             <a:extLst>
               <a:ext uri="{FF2B5EF4-FFF2-40B4-BE49-F238E27FC236}">
-                <a16:creationId xmlns:a16="http://schemas.microsoft.com/office/drawing/2014/main" id="{D5026071-C019-B388-9B20-A627587A444D}"/>
+                <a16:creationId xmlns:a16="http://schemas.microsoft.com/office/drawing/2014/main" id="{54AF3798-E1B7-4493-0491-F207CB59103D}"/>
               </a:ext>
             </a:extLst>
           </p:cNvPr>
@@ -1185,7 +1185,7 @@
           <a:bodyPr/>
           <a:lstStyle/>
           <a:p>
-            <a:fld id="{2A514CDA-1E74-420B-BC3B-A7D966BDE689}" type="slidenum">
+            <a:fld id="{9710AAFE-4C88-4438-AE64-610A72457F90}" type="slidenum">
               <a:rPr lang="en-US" smtClean="0"/>
               <a:t>‹#›</a:t>
             </a:fld>
@@ -1196,7 +1196,7 @@
     </p:spTree>
     <p:extLst>
       <p:ext uri="{BB962C8B-B14F-4D97-AF65-F5344CB8AC3E}">
-        <p14:creationId xmlns:p14="http://schemas.microsoft.com/office/powerpoint/2010/main" val="3805601201"/>
+        <p14:creationId xmlns:p14="http://schemas.microsoft.com/office/powerpoint/2010/main" val="440722096"/>
       </p:ext>
     </p:extLst>
   </p:cSld>
@@ -1228,7 +1228,7 @@
           <p:cNvPr id="2" name="Title 1">
             <a:extLst>
               <a:ext uri="{FF2B5EF4-FFF2-40B4-BE49-F238E27FC236}">
-                <a16:creationId xmlns:a16="http://schemas.microsoft.com/office/drawing/2014/main" id="{8FE9BCAD-2800-126F-E1E4-253CACC3763E}"/>
+                <a16:creationId xmlns:a16="http://schemas.microsoft.com/office/drawing/2014/main" id="{7D7F50B5-0E83-4134-D5C7-0352DB93E04C}"/>
               </a:ext>
             </a:extLst>
           </p:cNvPr>
@@ -1256,7 +1256,7 @@
           <p:cNvPr id="3" name="Content Placeholder 2">
             <a:extLst>
               <a:ext uri="{FF2B5EF4-FFF2-40B4-BE49-F238E27FC236}">
-                <a16:creationId xmlns:a16="http://schemas.microsoft.com/office/drawing/2014/main" id="{8D588879-87D3-E257-85D8-F947B15B33EA}"/>
+                <a16:creationId xmlns:a16="http://schemas.microsoft.com/office/drawing/2014/main" id="{6D81E42E-3765-0C72-C9A5-E9F437FCC8EE}"/>
               </a:ext>
             </a:extLst>
           </p:cNvPr>
@@ -1318,7 +1318,7 @@
           <p:cNvPr id="4" name="Content Placeholder 3">
             <a:extLst>
               <a:ext uri="{FF2B5EF4-FFF2-40B4-BE49-F238E27FC236}">
-                <a16:creationId xmlns:a16="http://schemas.microsoft.com/office/drawing/2014/main" id="{F2A13909-1D0D-9BF7-BC41-CAD18230BB5E}"/>
+                <a16:creationId xmlns:a16="http://schemas.microsoft.com/office/drawing/2014/main" id="{CBF50B8F-FEA1-C169-313B-21665459A90B}"/>
               </a:ext>
             </a:extLst>
           </p:cNvPr>
@@ -1380,7 +1380,7 @@
           <p:cNvPr id="5" name="Date Placeholder 4">
             <a:extLst>
               <a:ext uri="{FF2B5EF4-FFF2-40B4-BE49-F238E27FC236}">
-                <a16:creationId xmlns:a16="http://schemas.microsoft.com/office/drawing/2014/main" id="{360920F5-2570-B826-F8B0-5C68B48175D6}"/>
+                <a16:creationId xmlns:a16="http://schemas.microsoft.com/office/drawing/2014/main" id="{A377C299-439C-1AD1-DE2B-B6F5BB81B42F}"/>
               </a:ext>
             </a:extLst>
           </p:cNvPr>
@@ -1396,7 +1396,7 @@
           <a:bodyPr/>
           <a:lstStyle/>
           <a:p>
-            <a:fld id="{FD3911C1-3A98-4A4A-AB0A-8F4CBA820BBB}" type="datetimeFigureOut">
+            <a:fld id="{0D6085B6-32CC-41D7-BE48-8EC3E5D75128}" type="datetimeFigureOut">
               <a:rPr lang="en-US" smtClean="0"/>
               <a:t>5/14/2026</a:t>
             </a:fld>
@@ -1409,7 +1409,7 @@
           <p:cNvPr id="6" name="Footer Placeholder 5">
             <a:extLst>
               <a:ext uri="{FF2B5EF4-FFF2-40B4-BE49-F238E27FC236}">
-                <a16:creationId xmlns:a16="http://schemas.microsoft.com/office/drawing/2014/main" id="{C01DC1CD-3251-DAA0-A9E7-3E6103A3B6CB}"/>
+                <a16:creationId xmlns:a16="http://schemas.microsoft.com/office/drawing/2014/main" id="{C7C07836-DD65-8E00-228D-E271E4E59397}"/>
               </a:ext>
             </a:extLst>
           </p:cNvPr>
@@ -1434,7 +1434,7 @@
           <p:cNvPr id="7" name="Slide Number Placeholder 6">
             <a:extLst>
               <a:ext uri="{FF2B5EF4-FFF2-40B4-BE49-F238E27FC236}">
-                <a16:creationId xmlns:a16="http://schemas.microsoft.com/office/drawing/2014/main" id="{01DDC890-65C0-851F-E149-E423DF239860}"/>
+                <a16:creationId xmlns:a16="http://schemas.microsoft.com/office/drawing/2014/main" id="{6C5A78E4-08E9-0083-69D3-C2655A5166BC}"/>
               </a:ext>
             </a:extLst>
           </p:cNvPr>
@@ -1450,7 +1450,7 @@
           <a:bodyPr/>
           <a:lstStyle/>
           <a:p>
-            <a:fld id="{2A514CDA-1E74-420B-BC3B-A7D966BDE689}" type="slidenum">
+            <a:fld id="{9710AAFE-4C88-4438-AE64-610A72457F90}" type="slidenum">
               <a:rPr lang="en-US" smtClean="0"/>
               <a:t>‹#›</a:t>
             </a:fld>
@@ -1461,7 +1461,7 @@
     </p:spTree>
     <p:extLst>
       <p:ext uri="{BB962C8B-B14F-4D97-AF65-F5344CB8AC3E}">
-        <p14:creationId xmlns:p14="http://schemas.microsoft.com/office/powerpoint/2010/main" val="3189305612"/>
+        <p14:creationId xmlns:p14="http://schemas.microsoft.com/office/powerpoint/2010/main" val="198118022"/>
       </p:ext>
     </p:extLst>
   </p:cSld>
@@ -1493,7 +1493,7 @@
           <p:cNvPr id="2" name="Title 1">
             <a:extLst>
               <a:ext uri="{FF2B5EF4-FFF2-40B4-BE49-F238E27FC236}">
-                <a16:creationId xmlns:a16="http://schemas.microsoft.com/office/drawing/2014/main" id="{A9A3CE81-2770-9323-9AE9-5E36D667E247}"/>
+                <a16:creationId xmlns:a16="http://schemas.microsoft.com/office/drawing/2014/main" id="{0070822E-7B37-EFC6-0091-E57B1DD70509}"/>
               </a:ext>
             </a:extLst>
           </p:cNvPr>
@@ -1526,7 +1526,7 @@
           <p:cNvPr id="3" name="Text Placeholder 2">
             <a:extLst>
               <a:ext uri="{FF2B5EF4-FFF2-40B4-BE49-F238E27FC236}">
-                <a16:creationId xmlns:a16="http://schemas.microsoft.com/office/drawing/2014/main" id="{5E2037D7-280E-28BA-21FA-0CCF5D46E2B4}"/>
+                <a16:creationId xmlns:a16="http://schemas.microsoft.com/office/drawing/2014/main" id="{EF6792EB-ECD2-ADB3-C6DA-48C687C5FDBF}"/>
               </a:ext>
             </a:extLst>
           </p:cNvPr>
@@ -1597,7 +1597,7 @@
           <p:cNvPr id="4" name="Content Placeholder 3">
             <a:extLst>
               <a:ext uri="{FF2B5EF4-FFF2-40B4-BE49-F238E27FC236}">
-                <a16:creationId xmlns:a16="http://schemas.microsoft.com/office/drawing/2014/main" id="{D9E85550-EA6C-1031-62B9-AB8C309374AC}"/>
+                <a16:creationId xmlns:a16="http://schemas.microsoft.com/office/drawing/2014/main" id="{80B805AB-7206-08E7-B7B1-AC2596C832D7}"/>
               </a:ext>
             </a:extLst>
           </p:cNvPr>
@@ -1659,7 +1659,7 @@
           <p:cNvPr id="5" name="Text Placeholder 4">
             <a:extLst>
               <a:ext uri="{FF2B5EF4-FFF2-40B4-BE49-F238E27FC236}">
-                <a16:creationId xmlns:a16="http://schemas.microsoft.com/office/drawing/2014/main" id="{70C65EED-A775-21A9-3292-FC264D76DFF0}"/>
+                <a16:creationId xmlns:a16="http://schemas.microsoft.com/office/drawing/2014/main" id="{8C4D22D7-B259-F758-E079-B3D5BD8DD149}"/>
               </a:ext>
             </a:extLst>
           </p:cNvPr>
@@ -1730,7 +1730,7 @@
           <p:cNvPr id="6" name="Content Placeholder 5">
             <a:extLst>
               <a:ext uri="{FF2B5EF4-FFF2-40B4-BE49-F238E27FC236}">
-                <a16:creationId xmlns:a16="http://schemas.microsoft.com/office/drawing/2014/main" id="{12D3E6ED-0718-013B-ACFC-6429EF9D577C}"/>
+                <a16:creationId xmlns:a16="http://schemas.microsoft.com/office/drawing/2014/main" id="{AABB1B16-BA9C-2422-12E8-B2B61EDBD084}"/>
               </a:ext>
             </a:extLst>
           </p:cNvPr>
@@ -1792,7 +1792,7 @@
           <p:cNvPr id="7" name="Date Placeholder 6">
             <a:extLst>
               <a:ext uri="{FF2B5EF4-FFF2-40B4-BE49-F238E27FC236}">
-                <a16:creationId xmlns:a16="http://schemas.microsoft.com/office/drawing/2014/main" id="{D852495D-6747-2BB4-49EA-79DF8BC1940A}"/>
+                <a16:creationId xmlns:a16="http://schemas.microsoft.com/office/drawing/2014/main" id="{F8AC822F-C867-2F6E-0676-55661CD0DD2B}"/>
               </a:ext>
             </a:extLst>
           </p:cNvPr>
@@ -1808,7 +1808,7 @@
           <a:bodyPr/>
           <a:lstStyle/>
           <a:p>
-            <a:fld id="{FD3911C1-3A98-4A4A-AB0A-8F4CBA820BBB}" type="datetimeFigureOut">
+            <a:fld id="{0D6085B6-32CC-41D7-BE48-8EC3E5D75128}" type="datetimeFigureOut">
               <a:rPr lang="en-US" smtClean="0"/>
               <a:t>5/14/2026</a:t>
             </a:fld>
@@ -1821,7 +1821,7 @@
           <p:cNvPr id="8" name="Footer Placeholder 7">
             <a:extLst>
               <a:ext uri="{FF2B5EF4-FFF2-40B4-BE49-F238E27FC236}">
-                <a16:creationId xmlns:a16="http://schemas.microsoft.com/office/drawing/2014/main" id="{FC183E17-9366-C5A5-5FA5-9962BB2E5F81}"/>
+                <a16:creationId xmlns:a16="http://schemas.microsoft.com/office/drawing/2014/main" id="{8ACC4C58-494C-521B-75FC-1B2B738BD1FE}"/>
               </a:ext>
             </a:extLst>
           </p:cNvPr>
@@ -1846,7 +1846,7 @@
           <p:cNvPr id="9" name="Slide Number Placeholder 8">
             <a:extLst>
               <a:ext uri="{FF2B5EF4-FFF2-40B4-BE49-F238E27FC236}">
-                <a16:creationId xmlns:a16="http://schemas.microsoft.com/office/drawing/2014/main" id="{FA4DCCF7-F424-BEEE-DB92-B74D6C504830}"/>
+                <a16:creationId xmlns:a16="http://schemas.microsoft.com/office/drawing/2014/main" id="{A2A81D13-6A8C-D976-4268-B2FDE106A613}"/>
               </a:ext>
             </a:extLst>
           </p:cNvPr>
@@ -1862,7 +1862,7 @@
           <a:bodyPr/>
           <a:lstStyle/>
           <a:p>
-            <a:fld id="{2A514CDA-1E74-420B-BC3B-A7D966BDE689}" type="slidenum">
+            <a:fld id="{9710AAFE-4C88-4438-AE64-610A72457F90}" type="slidenum">
               <a:rPr lang="en-US" smtClean="0"/>
               <a:t>‹#›</a:t>
             </a:fld>
@@ -1873,7 +1873,7 @@
     </p:spTree>
     <p:extLst>
       <p:ext uri="{BB962C8B-B14F-4D97-AF65-F5344CB8AC3E}">
-        <p14:creationId xmlns:p14="http://schemas.microsoft.com/office/powerpoint/2010/main" val="259401496"/>
+        <p14:creationId xmlns:p14="http://schemas.microsoft.com/office/powerpoint/2010/main" val="3830625376"/>
       </p:ext>
     </p:extLst>
   </p:cSld>
@@ -1905,7 +1905,7 @@
           <p:cNvPr id="2" name="Title 1">
             <a:extLst>
               <a:ext uri="{FF2B5EF4-FFF2-40B4-BE49-F238E27FC236}">
-                <a16:creationId xmlns:a16="http://schemas.microsoft.com/office/drawing/2014/main" id="{2E988770-0121-E8C1-D515-812D2A094E97}"/>
+                <a16:creationId xmlns:a16="http://schemas.microsoft.com/office/drawing/2014/main" id="{C4D2A82E-CA35-48D0-97AB-BD83FDD831F9}"/>
               </a:ext>
             </a:extLst>
           </p:cNvPr>
@@ -1933,7 +1933,7 @@
           <p:cNvPr id="3" name="Date Placeholder 2">
             <a:extLst>
               <a:ext uri="{FF2B5EF4-FFF2-40B4-BE49-F238E27FC236}">
-                <a16:creationId xmlns:a16="http://schemas.microsoft.com/office/drawing/2014/main" id="{6027B6E6-7B1A-3C2A-4775-7C8B32E7589D}"/>
+                <a16:creationId xmlns:a16="http://schemas.microsoft.com/office/drawing/2014/main" id="{DC4B90ED-683E-286E-844F-A9F85276403A}"/>
               </a:ext>
             </a:extLst>
           </p:cNvPr>
@@ -1949,7 +1949,7 @@
           <a:bodyPr/>
           <a:lstStyle/>
           <a:p>
-            <a:fld id="{FD3911C1-3A98-4A4A-AB0A-8F4CBA820BBB}" type="datetimeFigureOut">
+            <a:fld id="{0D6085B6-32CC-41D7-BE48-8EC3E5D75128}" type="datetimeFigureOut">
               <a:rPr lang="en-US" smtClean="0"/>
               <a:t>5/14/2026</a:t>
             </a:fld>
@@ -1962,7 +1962,7 @@
           <p:cNvPr id="4" name="Footer Placeholder 3">
             <a:extLst>
               <a:ext uri="{FF2B5EF4-FFF2-40B4-BE49-F238E27FC236}">
-                <a16:creationId xmlns:a16="http://schemas.microsoft.com/office/drawing/2014/main" id="{5409056E-D293-4451-3C2A-45161077C50E}"/>
+                <a16:creationId xmlns:a16="http://schemas.microsoft.com/office/drawing/2014/main" id="{8F950154-0ED2-F432-927B-F7C63BB7BC9E}"/>
               </a:ext>
             </a:extLst>
           </p:cNvPr>
@@ -1987,7 +1987,7 @@
           <p:cNvPr id="5" name="Slide Number Placeholder 4">
             <a:extLst>
               <a:ext uri="{FF2B5EF4-FFF2-40B4-BE49-F238E27FC236}">
-                <a16:creationId xmlns:a16="http://schemas.microsoft.com/office/drawing/2014/main" id="{83A02062-94D1-71E6-EF00-3D66B4929C66}"/>
+                <a16:creationId xmlns:a16="http://schemas.microsoft.com/office/drawing/2014/main" id="{C7F602A2-0EFB-BB25-80D2-101AEC304881}"/>
               </a:ext>
             </a:extLst>
           </p:cNvPr>
@@ -2003,7 +2003,7 @@
           <a:bodyPr/>
           <a:lstStyle/>
           <a:p>
-            <a:fld id="{2A514CDA-1E74-420B-BC3B-A7D966BDE689}" type="slidenum">
+            <a:fld id="{9710AAFE-4C88-4438-AE64-610A72457F90}" type="slidenum">
               <a:rPr lang="en-US" smtClean="0"/>
               <a:t>‹#›</a:t>
             </a:fld>
@@ -2014,7 +2014,7 @@
     </p:spTree>
     <p:extLst>
       <p:ext uri="{BB962C8B-B14F-4D97-AF65-F5344CB8AC3E}">
-        <p14:creationId xmlns:p14="http://schemas.microsoft.com/office/powerpoint/2010/main" val="703415452"/>
+        <p14:creationId xmlns:p14="http://schemas.microsoft.com/office/powerpoint/2010/main" val="2650602505"/>
       </p:ext>
     </p:extLst>
   </p:cSld>
@@ -2046,7 +2046,7 @@
           <p:cNvPr id="2" name="Date Placeholder 1">
             <a:extLst>
               <a:ext uri="{FF2B5EF4-FFF2-40B4-BE49-F238E27FC236}">
-                <a16:creationId xmlns:a16="http://schemas.microsoft.com/office/drawing/2014/main" id="{EDA475D4-B511-5DA8-6AA5-9D4F079067E7}"/>
+                <a16:creationId xmlns:a16="http://schemas.microsoft.com/office/drawing/2014/main" id="{C0C44774-9059-CC23-5BF2-21CFE188A8BE}"/>
               </a:ext>
             </a:extLst>
           </p:cNvPr>
@@ -2062,7 +2062,7 @@
           <a:bodyPr/>
           <a:lstStyle/>
           <a:p>
-            <a:fld id="{FD3911C1-3A98-4A4A-AB0A-8F4CBA820BBB}" type="datetimeFigureOut">
+            <a:fld id="{0D6085B6-32CC-41D7-BE48-8EC3E5D75128}" type="datetimeFigureOut">
               <a:rPr lang="en-US" smtClean="0"/>
               <a:t>5/14/2026</a:t>
             </a:fld>
@@ -2075,7 +2075,7 @@
           <p:cNvPr id="3" name="Footer Placeholder 2">
             <a:extLst>
               <a:ext uri="{FF2B5EF4-FFF2-40B4-BE49-F238E27FC236}">
-                <a16:creationId xmlns:a16="http://schemas.microsoft.com/office/drawing/2014/main" id="{6D3C8573-E078-9FA0-2CC7-05B35B0A308D}"/>
+                <a16:creationId xmlns:a16="http://schemas.microsoft.com/office/drawing/2014/main" id="{9168EF5B-931E-21DB-0B9B-FF63439474BE}"/>
               </a:ext>
             </a:extLst>
           </p:cNvPr>
@@ -2100,7 +2100,7 @@
           <p:cNvPr id="4" name="Slide Number Placeholder 3">
             <a:extLst>
               <a:ext uri="{FF2B5EF4-FFF2-40B4-BE49-F238E27FC236}">
-                <a16:creationId xmlns:a16="http://schemas.microsoft.com/office/drawing/2014/main" id="{4B3762DF-C334-C877-5A32-D91C89A73220}"/>
+                <a16:creationId xmlns:a16="http://schemas.microsoft.com/office/drawing/2014/main" id="{766F68F8-C22D-BAB2-A640-6A409ECE2383}"/>
               </a:ext>
             </a:extLst>
           </p:cNvPr>
@@ -2116,7 +2116,7 @@
           <a:bodyPr/>
           <a:lstStyle/>
           <a:p>
-            <a:fld id="{2A514CDA-1E74-420B-BC3B-A7D966BDE689}" type="slidenum">
+            <a:fld id="{9710AAFE-4C88-4438-AE64-610A72457F90}" type="slidenum">
               <a:rPr lang="en-US" smtClean="0"/>
               <a:t>‹#›</a:t>
             </a:fld>
@@ -2127,7 +2127,7 @@
     </p:spTree>
     <p:extLst>
       <p:ext uri="{BB962C8B-B14F-4D97-AF65-F5344CB8AC3E}">
-        <p14:creationId xmlns:p14="http://schemas.microsoft.com/office/powerpoint/2010/main" val="3559940661"/>
+        <p14:creationId xmlns:p14="http://schemas.microsoft.com/office/powerpoint/2010/main" val="4172025909"/>
       </p:ext>
     </p:extLst>
   </p:cSld>
@@ -2159,7 +2159,7 @@
           <p:cNvPr id="2" name="Title 1">
             <a:extLst>
               <a:ext uri="{FF2B5EF4-FFF2-40B4-BE49-F238E27FC236}">
-                <a16:creationId xmlns:a16="http://schemas.microsoft.com/office/drawing/2014/main" id="{5B6A98CE-20D1-FB28-F54B-41F1F3FF9404}"/>
+                <a16:creationId xmlns:a16="http://schemas.microsoft.com/office/drawing/2014/main" id="{A0EF9C19-EE32-5637-16D4-A449D18C73E6}"/>
               </a:ext>
             </a:extLst>
           </p:cNvPr>
@@ -2196,7 +2196,7 @@
           <p:cNvPr id="3" name="Content Placeholder 2">
             <a:extLst>
               <a:ext uri="{FF2B5EF4-FFF2-40B4-BE49-F238E27FC236}">
-                <a16:creationId xmlns:a16="http://schemas.microsoft.com/office/drawing/2014/main" id="{FEA9A833-7679-D0E4-2009-2E311983502A}"/>
+                <a16:creationId xmlns:a16="http://schemas.microsoft.com/office/drawing/2014/main" id="{E1BCFA47-22F2-8AC0-CCA7-3217AC2D0737}"/>
               </a:ext>
             </a:extLst>
           </p:cNvPr>
@@ -2286,7 +2286,7 @@
           <p:cNvPr id="4" name="Text Placeholder 3">
             <a:extLst>
               <a:ext uri="{FF2B5EF4-FFF2-40B4-BE49-F238E27FC236}">
-                <a16:creationId xmlns:a16="http://schemas.microsoft.com/office/drawing/2014/main" id="{063C0431-B3CE-A85F-9F10-C60EFF94EE60}"/>
+                <a16:creationId xmlns:a16="http://schemas.microsoft.com/office/drawing/2014/main" id="{3A22DD5F-F67D-2729-275C-E7DF4980EA39}"/>
               </a:ext>
             </a:extLst>
           </p:cNvPr>
@@ -2357,7 +2357,7 @@
           <p:cNvPr id="5" name="Date Placeholder 4">
             <a:extLst>
               <a:ext uri="{FF2B5EF4-FFF2-40B4-BE49-F238E27FC236}">
-                <a16:creationId xmlns:a16="http://schemas.microsoft.com/office/drawing/2014/main" id="{2606073F-B7BE-532E-9630-FDA339526353}"/>
+                <a16:creationId xmlns:a16="http://schemas.microsoft.com/office/drawing/2014/main" id="{497D5990-25B7-5F56-59FF-194F66F60211}"/>
               </a:ext>
             </a:extLst>
           </p:cNvPr>
@@ -2373,7 +2373,7 @@
           <a:bodyPr/>
           <a:lstStyle/>
           <a:p>
-            <a:fld id="{FD3911C1-3A98-4A4A-AB0A-8F4CBA820BBB}" type="datetimeFigureOut">
+            <a:fld id="{0D6085B6-32CC-41D7-BE48-8EC3E5D75128}" type="datetimeFigureOut">
               <a:rPr lang="en-US" smtClean="0"/>
               <a:t>5/14/2026</a:t>
             </a:fld>
@@ -2386,7 +2386,7 @@
           <p:cNvPr id="6" name="Footer Placeholder 5">
             <a:extLst>
               <a:ext uri="{FF2B5EF4-FFF2-40B4-BE49-F238E27FC236}">
-                <a16:creationId xmlns:a16="http://schemas.microsoft.com/office/drawing/2014/main" id="{E30F1D0B-26A2-A37F-A86D-75E70F784349}"/>
+                <a16:creationId xmlns:a16="http://schemas.microsoft.com/office/drawing/2014/main" id="{6816D861-758F-E371-B43E-9CE170EC9F6A}"/>
               </a:ext>
             </a:extLst>
           </p:cNvPr>
@@ -2411,7 +2411,7 @@
           <p:cNvPr id="7" name="Slide Number Placeholder 6">
             <a:extLst>
               <a:ext uri="{FF2B5EF4-FFF2-40B4-BE49-F238E27FC236}">
-                <a16:creationId xmlns:a16="http://schemas.microsoft.com/office/drawing/2014/main" id="{E83B46B1-1FA2-C9DA-B78E-6CAFD4F8EDFD}"/>
+                <a16:creationId xmlns:a16="http://schemas.microsoft.com/office/drawing/2014/main" id="{C581EAD5-1946-8474-DBDC-BE3F75AAAE11}"/>
               </a:ext>
             </a:extLst>
           </p:cNvPr>
@@ -2427,7 +2427,7 @@
           <a:bodyPr/>
           <a:lstStyle/>
           <a:p>
-            <a:fld id="{2A514CDA-1E74-420B-BC3B-A7D966BDE689}" type="slidenum">
+            <a:fld id="{9710AAFE-4C88-4438-AE64-610A72457F90}" type="slidenum">
               <a:rPr lang="en-US" smtClean="0"/>
               <a:t>‹#›</a:t>
             </a:fld>
@@ -2438,7 +2438,7 @@
     </p:spTree>
     <p:extLst>
       <p:ext uri="{BB962C8B-B14F-4D97-AF65-F5344CB8AC3E}">
-        <p14:creationId xmlns:p14="http://schemas.microsoft.com/office/powerpoint/2010/main" val="1375399903"/>
+        <p14:creationId xmlns:p14="http://schemas.microsoft.com/office/powerpoint/2010/main" val="510042166"/>
       </p:ext>
     </p:extLst>
   </p:cSld>
@@ -2470,7 +2470,7 @@
           <p:cNvPr id="2" name="Title 1">
             <a:extLst>
               <a:ext uri="{FF2B5EF4-FFF2-40B4-BE49-F238E27FC236}">
-                <a16:creationId xmlns:a16="http://schemas.microsoft.com/office/drawing/2014/main" id="{7C39DEAD-5E6F-BC6D-F715-7905FFA7A1C1}"/>
+                <a16:creationId xmlns:a16="http://schemas.microsoft.com/office/drawing/2014/main" id="{37B0E23B-7447-143D-114D-168CF9608F67}"/>
               </a:ext>
             </a:extLst>
           </p:cNvPr>
@@ -2507,7 +2507,7 @@
           <p:cNvPr id="3" name="Picture Placeholder 2">
             <a:extLst>
               <a:ext uri="{FF2B5EF4-FFF2-40B4-BE49-F238E27FC236}">
-                <a16:creationId xmlns:a16="http://schemas.microsoft.com/office/drawing/2014/main" id="{EAD421E2-AA41-2F78-7AB4-789EF983BC10}"/>
+                <a16:creationId xmlns:a16="http://schemas.microsoft.com/office/drawing/2014/main" id="{05DFF00E-EB96-D9CC-0985-6D16F9F5D9C6}"/>
               </a:ext>
             </a:extLst>
           </p:cNvPr>
@@ -2574,7 +2574,7 @@
           <p:cNvPr id="4" name="Text Placeholder 3">
             <a:extLst>
               <a:ext uri="{FF2B5EF4-FFF2-40B4-BE49-F238E27FC236}">
-                <a16:creationId xmlns:a16="http://schemas.microsoft.com/office/drawing/2014/main" id="{A6E9DAB4-2FB0-8879-113B-2538E68639F6}"/>
+                <a16:creationId xmlns:a16="http://schemas.microsoft.com/office/drawing/2014/main" id="{1BCE1F4B-9E80-12CB-868F-485E9C9FD744}"/>
               </a:ext>
             </a:extLst>
           </p:cNvPr>
@@ -2645,7 +2645,7 @@
           <p:cNvPr id="5" name="Date Placeholder 4">
             <a:extLst>
               <a:ext uri="{FF2B5EF4-FFF2-40B4-BE49-F238E27FC236}">
-                <a16:creationId xmlns:a16="http://schemas.microsoft.com/office/drawing/2014/main" id="{D58CE92E-F428-2DD4-E1E6-58D4DDCE8FB8}"/>
+                <a16:creationId xmlns:a16="http://schemas.microsoft.com/office/drawing/2014/main" id="{00994CCC-9DD5-E28C-C5AE-BF710C00BC19}"/>
               </a:ext>
             </a:extLst>
           </p:cNvPr>
@@ -2661,7 +2661,7 @@
           <a:bodyPr/>
           <a:lstStyle/>
           <a:p>
-            <a:fld id="{FD3911C1-3A98-4A4A-AB0A-8F4CBA820BBB}" type="datetimeFigureOut">
+            <a:fld id="{0D6085B6-32CC-41D7-BE48-8EC3E5D75128}" type="datetimeFigureOut">
               <a:rPr lang="en-US" smtClean="0"/>
               <a:t>5/14/2026</a:t>
             </a:fld>
@@ -2674,7 +2674,7 @@
           <p:cNvPr id="6" name="Footer Placeholder 5">
             <a:extLst>
               <a:ext uri="{FF2B5EF4-FFF2-40B4-BE49-F238E27FC236}">
-                <a16:creationId xmlns:a16="http://schemas.microsoft.com/office/drawing/2014/main" id="{AE0A778C-4806-DB66-C450-DD961589C84E}"/>
+                <a16:creationId xmlns:a16="http://schemas.microsoft.com/office/drawing/2014/main" id="{10B7A04D-5D70-FF77-91A7-16F1E6256866}"/>
               </a:ext>
             </a:extLst>
           </p:cNvPr>
@@ -2699,7 +2699,7 @@
           <p:cNvPr id="7" name="Slide Number Placeholder 6">
             <a:extLst>
               <a:ext uri="{FF2B5EF4-FFF2-40B4-BE49-F238E27FC236}">
-                <a16:creationId xmlns:a16="http://schemas.microsoft.com/office/drawing/2014/main" id="{85A9F7C9-6158-E068-6CBF-4BBBE6116C5E}"/>
+                <a16:creationId xmlns:a16="http://schemas.microsoft.com/office/drawing/2014/main" id="{F6AC51D4-79B7-E558-B17A-7F1CA749B952}"/>
               </a:ext>
             </a:extLst>
           </p:cNvPr>
@@ -2715,7 +2715,7 @@
           <a:bodyPr/>
           <a:lstStyle/>
           <a:p>
-            <a:fld id="{2A514CDA-1E74-420B-BC3B-A7D966BDE689}" type="slidenum">
+            <a:fld id="{9710AAFE-4C88-4438-AE64-610A72457F90}" type="slidenum">
               <a:rPr lang="en-US" smtClean="0"/>
               <a:t>‹#›</a:t>
             </a:fld>
@@ -2726,7 +2726,7 @@
     </p:spTree>
     <p:extLst>
       <p:ext uri="{BB962C8B-B14F-4D97-AF65-F5344CB8AC3E}">
-        <p14:creationId xmlns:p14="http://schemas.microsoft.com/office/powerpoint/2010/main" val="1455450957"/>
+        <p14:creationId xmlns:p14="http://schemas.microsoft.com/office/powerpoint/2010/main" val="2300728520"/>
       </p:ext>
     </p:extLst>
   </p:cSld>
@@ -2763,7 +2763,7 @@
           <p:cNvPr id="2" name="Title Placeholder 1">
             <a:extLst>
               <a:ext uri="{FF2B5EF4-FFF2-40B4-BE49-F238E27FC236}">
-                <a16:creationId xmlns:a16="http://schemas.microsoft.com/office/drawing/2014/main" id="{040BE87B-8B5D-E4C1-3E13-20DD49202BA2}"/>
+                <a16:creationId xmlns:a16="http://schemas.microsoft.com/office/drawing/2014/main" id="{AB7A57E2-F9B3-E82F-8783-CAD3C42F3056}"/>
               </a:ext>
             </a:extLst>
           </p:cNvPr>
@@ -2801,7 +2801,7 @@
           <p:cNvPr id="3" name="Text Placeholder 2">
             <a:extLst>
               <a:ext uri="{FF2B5EF4-FFF2-40B4-BE49-F238E27FC236}">
-                <a16:creationId xmlns:a16="http://schemas.microsoft.com/office/drawing/2014/main" id="{259A42AD-27F1-28E8-162B-7662132B8C6F}"/>
+                <a16:creationId xmlns:a16="http://schemas.microsoft.com/office/drawing/2014/main" id="{4924860B-0AD5-99CC-7A6B-CFC2481411D4}"/>
               </a:ext>
             </a:extLst>
           </p:cNvPr>
@@ -2868,7 +2868,7 @@
           <p:cNvPr id="4" name="Date Placeholder 3">
             <a:extLst>
               <a:ext uri="{FF2B5EF4-FFF2-40B4-BE49-F238E27FC236}">
-                <a16:creationId xmlns:a16="http://schemas.microsoft.com/office/drawing/2014/main" id="{01A85062-32A8-8585-363E-D3B6C519A2B6}"/>
+                <a16:creationId xmlns:a16="http://schemas.microsoft.com/office/drawing/2014/main" id="{5DDB1F70-9115-F03A-E345-C53C6524BAC3}"/>
               </a:ext>
             </a:extLst>
           </p:cNvPr>
@@ -2902,7 +2902,7 @@
             </a:lvl1pPr>
           </a:lstStyle>
           <a:p>
-            <a:fld id="{FD3911C1-3A98-4A4A-AB0A-8F4CBA820BBB}" type="datetimeFigureOut">
+            <a:fld id="{0D6085B6-32CC-41D7-BE48-8EC3E5D75128}" type="datetimeFigureOut">
               <a:rPr lang="en-US" smtClean="0"/>
               <a:t>5/14/2026</a:t>
             </a:fld>
@@ -2915,7 +2915,7 @@
           <p:cNvPr id="5" name="Footer Placeholder 4">
             <a:extLst>
               <a:ext uri="{FF2B5EF4-FFF2-40B4-BE49-F238E27FC236}">
-                <a16:creationId xmlns:a16="http://schemas.microsoft.com/office/drawing/2014/main" id="{1A8B5B07-097C-6480-BD78-4CB0DA7B2343}"/>
+                <a16:creationId xmlns:a16="http://schemas.microsoft.com/office/drawing/2014/main" id="{24DB9A06-1F74-345A-540B-E0540F450DFC}"/>
               </a:ext>
             </a:extLst>
           </p:cNvPr>
@@ -2958,7 +2958,7 @@
           <p:cNvPr id="6" name="Slide Number Placeholder 5">
             <a:extLst>
               <a:ext uri="{FF2B5EF4-FFF2-40B4-BE49-F238E27FC236}">
-                <a16:creationId xmlns:a16="http://schemas.microsoft.com/office/drawing/2014/main" id="{549E8EB9-8547-C00C-D465-884E0CD53F02}"/>
+                <a16:creationId xmlns:a16="http://schemas.microsoft.com/office/drawing/2014/main" id="{F408293E-901E-6BA9-1803-974DAA2B8629}"/>
               </a:ext>
             </a:extLst>
           </p:cNvPr>
@@ -2992,7 +2992,7 @@
             </a:lvl1pPr>
           </a:lstStyle>
           <a:p>
-            <a:fld id="{2A514CDA-1E74-420B-BC3B-A7D966BDE689}" type="slidenum">
+            <a:fld id="{9710AAFE-4C88-4438-AE64-610A72457F90}" type="slidenum">
               <a:rPr lang="en-US" smtClean="0"/>
               <a:t>‹#›</a:t>
             </a:fld>
@@ -3003,7 +3003,7 @@
     </p:spTree>
     <p:extLst>
       <p:ext uri="{BB962C8B-B14F-4D97-AF65-F5344CB8AC3E}">
-        <p14:creationId xmlns:p14="http://schemas.microsoft.com/office/powerpoint/2010/main" val="1208790470"/>
+        <p14:creationId xmlns:p14="http://schemas.microsoft.com/office/powerpoint/2010/main" val="2397310641"/>
       </p:ext>
     </p:extLst>
   </p:cSld>
@@ -3324,7 +3324,7 @@
     </p:spTree>
     <p:extLst>
       <p:ext uri="{BB962C8B-B14F-4D97-AF65-F5344CB8AC3E}">
-        <p14:creationId xmlns:p14="http://schemas.microsoft.com/office/powerpoint/2010/main" val="288382371"/>
+        <p14:creationId xmlns:p14="http://schemas.microsoft.com/office/powerpoint/2010/main" val="798629280"/>
       </p:ext>
     </p:extLst>
   </p:cSld>

</xml_diff>